<commit_message>
feat: add EventFlow campus event coordination platform client components and UI screens
</commit_message>
<xml_diff>
--- a/Capstone/EventFlow_Venue_Double_Booking_Interval_Scheduling.pptx
+++ b/Capstone/EventFlow_Venue_Double_Booking_Interval_Scheduling.pptx
@@ -13,6 +13,11 @@
     <p:sldId id="261" r:id="rId12"/>
     <p:sldId id="262" r:id="rId13"/>
     <p:sldId id="263" r:id="rId14"/>
+    <p:sldId id="264" r:id="rId15"/>
+    <p:sldId id="265" r:id="rId16"/>
+    <p:sldId id="266" r:id="rId17"/>
+    <p:sldId id="267" r:id="rId18"/>
+    <p:sldId id="268" r:id="rId19"/>
   </p:sldIdLst>
   <p:sldSz cx="12191695" cy="6858000" type="screen4x3"/>
   <p:notesSz cx="6858000" cy="9144000"/>
@@ -3679,8 +3684,3865 @@
               </a:defRPr>
             </a:pPr>
             <a:r>
-              <a:t>Slide 1 of 8</a:t>
-            </a:r>
+              <a:t>Slide 1 of 13</a:t>
+            </a:r>
+          </a:p>
+        </p:txBody>
+      </p:sp>
+    </p:spTree>
+  </p:cSld>
+  <p:clrMapOvr>
+    <a:masterClrMapping/>
+  </p:clrMapOvr>
+</p:sld>
+</file>
+
+<file path=ppt/slides/slide10.xml><?xml version="1.0" encoding="utf-8"?>
+<p:sld xmlns:a="http://schemas.openxmlformats.org/drawingml/2006/main" xmlns:p="http://schemas.openxmlformats.org/presentationml/2006/main" xmlns:r="http://schemas.openxmlformats.org/officeDocument/2006/relationships">
+  <p:cSld>
+    <p:spTree>
+      <p:nvGrpSpPr>
+        <p:cNvPr id="1" name=""/>
+        <p:cNvGrpSpPr/>
+        <p:nvPr/>
+      </p:nvGrpSpPr>
+      <p:grpSpPr/>
+      <p:sp>
+        <p:nvSpPr>
+          <p:cNvPr id="2" name="Rounded Rectangle 1"/>
+          <p:cNvSpPr/>
+          <p:nvPr/>
+        </p:nvSpPr>
+        <p:spPr>
+          <a:xfrm>
+            <a:off x="731520" y="411480"/>
+            <a:ext cx="4114800" cy="292608"/>
+          </a:xfrm>
+          <a:prstGeom prst="roundRect">
+            <a:avLst/>
+          </a:prstGeom>
+          <a:solidFill>
+            <a:srgbClr val="EEF2FF"/>
+          </a:solidFill>
+          <a:ln w="12700">
+            <a:solidFill>
+              <a:srgbClr val="C7D2FE"/>
+            </a:solidFill>
+          </a:ln>
+        </p:spPr>
+        <p:style>
+          <a:lnRef idx="1">
+            <a:schemeClr val="accent1"/>
+          </a:lnRef>
+          <a:fillRef idx="3">
+            <a:schemeClr val="accent1"/>
+          </a:fillRef>
+          <a:effectRef idx="2">
+            <a:schemeClr val="accent1"/>
+          </a:effectRef>
+          <a:fontRef idx="minor">
+            <a:schemeClr val="lt1"/>
+          </a:fontRef>
+        </p:style>
+        <p:txBody>
+          <a:bodyPr rtlCol="0" anchor="ctr" wrap="square" lIns="109728" tIns="36576"/>
+          <a:lstStyle/>
+          <a:p>
+            <a:pPr algn="ctr">
+              <a:defRPr sz="950" b="1">
+                <a:solidFill>
+                  <a:srgbClr val="312E81"/>
+                </a:solidFill>
+                <a:latin typeface="Calibri"/>
+              </a:defRPr>
+            </a:pPr>
+            <a:r>
+              <a:t>SOFTWARE ENGINEERING LIFECYCLE | PHASE 2</a:t>
+            </a:r>
+          </a:p>
+        </p:txBody>
+      </p:sp>
+      <p:sp>
+        <p:nvSpPr>
+          <p:cNvPr id="3" name="TextBox 2"/>
+          <p:cNvSpPr txBox="1"/>
+          <p:nvPr/>
+        </p:nvSpPr>
+        <p:spPr>
+          <a:xfrm>
+            <a:off x="731520" y="777240"/>
+            <a:ext cx="10698480" cy="868680"/>
+          </a:xfrm>
+          <a:prstGeom prst="rect">
+            <a:avLst/>
+          </a:prstGeom>
+          <a:noFill/>
+        </p:spPr>
+        <p:txBody>
+          <a:bodyPr wrap="square" lIns="0" tIns="0" rIns="0" bIns="0">
+            <a:spAutoFit/>
+          </a:bodyPr>
+          <a:lstStyle/>
+          <a:p>
+            <a:pPr>
+              <a:defRPr sz="2200" b="1">
+                <a:solidFill>
+                  <a:srgbClr val="1A365D"/>
+                </a:solidFill>
+                <a:latin typeface="Calibri"/>
+              </a:defRPr>
+            </a:pPr>
+            <a:r>
+              <a:t>Module 2: System Design &amp; Algorithmic Architecture</a:t>
+            </a:r>
+          </a:p>
+          <a:p>
+            <a:pPr>
+              <a:spcBef>
+                <a:spcPts val="300"/>
+              </a:spcBef>
+              <a:defRPr sz="1200">
+                <a:solidFill>
+                  <a:srgbClr val="64748B"/>
+                </a:solidFill>
+                <a:latin typeface="Calibri"/>
+              </a:defRPr>
+            </a:pPr>
+            <a:r>
+              <a:t>Component decomposition, relational entity-relationship modeling, and interval concurrency design</a:t>
+            </a:r>
+          </a:p>
+        </p:txBody>
+      </p:sp>
+      <p:sp>
+        <p:nvSpPr>
+          <p:cNvPr id="4" name="Rectangle 3"/>
+          <p:cNvSpPr/>
+          <p:nvPr/>
+        </p:nvSpPr>
+        <p:spPr>
+          <a:xfrm>
+            <a:off x="731520" y="1691640"/>
+            <a:ext cx="10725912" cy="18288"/>
+          </a:xfrm>
+          <a:prstGeom prst="rect">
+            <a:avLst/>
+          </a:prstGeom>
+          <a:solidFill>
+            <a:srgbClr val="E2E8F0"/>
+          </a:solidFill>
+          <a:ln>
+            <a:solidFill>
+              <a:srgbClr val="E2E8F0"/>
+            </a:solidFill>
+          </a:ln>
+        </p:spPr>
+        <p:style>
+          <a:lnRef idx="1">
+            <a:schemeClr val="accent1"/>
+          </a:lnRef>
+          <a:fillRef idx="3">
+            <a:schemeClr val="accent1"/>
+          </a:fillRef>
+          <a:effectRef idx="2">
+            <a:schemeClr val="accent1"/>
+          </a:effectRef>
+          <a:fontRef idx="minor">
+            <a:schemeClr val="lt1"/>
+          </a:fontRef>
+        </p:style>
+        <p:txBody>
+          <a:bodyPr rtlCol="0" anchor="ctr"/>
+          <a:lstStyle/>
+          <a:p>
+            <a:pPr algn="ctr"/>
+          </a:p>
+        </p:txBody>
+      </p:sp>
+      <p:sp>
+        <p:nvSpPr>
+          <p:cNvPr id="5" name="TextBox 4"/>
+          <p:cNvSpPr txBox="1"/>
+          <p:nvPr/>
+        </p:nvSpPr>
+        <p:spPr>
+          <a:xfrm>
+            <a:off x="731520" y="6400800"/>
+            <a:ext cx="7315200" cy="274320"/>
+          </a:xfrm>
+          <a:prstGeom prst="rect">
+            <a:avLst/>
+          </a:prstGeom>
+          <a:noFill/>
+        </p:spPr>
+        <p:txBody>
+          <a:bodyPr wrap="square" lIns="0" tIns="0">
+            <a:spAutoFit/>
+          </a:bodyPr>
+          <a:lstStyle/>
+          <a:p>
+            <a:pPr>
+              <a:defRPr sz="900">
+                <a:solidFill>
+                  <a:srgbClr val="64748B"/>
+                </a:solidFill>
+                <a:latin typeface="Calibri"/>
+              </a:defRPr>
+            </a:pPr>
+            <a:r>
+              <a:t>CSA1021 - Software Engineering | Capstone Project 2026 | Saveetha School of Engineering (SIMATS)</a:t>
+            </a:r>
+          </a:p>
+        </p:txBody>
+      </p:sp>
+      <p:sp>
+        <p:nvSpPr>
+          <p:cNvPr id="6" name="TextBox 5"/>
+          <p:cNvSpPr txBox="1"/>
+          <p:nvPr/>
+        </p:nvSpPr>
+        <p:spPr>
+          <a:xfrm>
+            <a:off x="9601200" y="6400800"/>
+            <a:ext cx="1828800" cy="274320"/>
+          </a:xfrm>
+          <a:prstGeom prst="rect">
+            <a:avLst/>
+          </a:prstGeom>
+          <a:noFill/>
+        </p:spPr>
+        <p:txBody>
+          <a:bodyPr wrap="square" rIns="0" tIns="0">
+            <a:spAutoFit/>
+          </a:bodyPr>
+          <a:lstStyle/>
+          <a:p>
+            <a:pPr algn="r">
+              <a:defRPr sz="900">
+                <a:solidFill>
+                  <a:srgbClr val="64748B"/>
+                </a:solidFill>
+                <a:latin typeface="Calibri"/>
+              </a:defRPr>
+            </a:pPr>
+            <a:r>
+              <a:t>Slide 10 of 13</a:t>
+            </a:r>
+          </a:p>
+        </p:txBody>
+      </p:sp>
+      <p:sp>
+        <p:nvSpPr>
+          <p:cNvPr id="7" name="Rounded Rectangle 6"/>
+          <p:cNvSpPr/>
+          <p:nvPr/>
+        </p:nvSpPr>
+        <p:spPr>
+          <a:xfrm>
+            <a:off x="731520" y="1874519"/>
+            <a:ext cx="3410712" cy="4297680"/>
+          </a:xfrm>
+          <a:prstGeom prst="roundRect">
+            <a:avLst/>
+          </a:prstGeom>
+          <a:solidFill>
+            <a:srgbClr val="F8FAFC"/>
+          </a:solidFill>
+          <a:ln w="12700">
+            <a:solidFill>
+              <a:srgbClr val="E2E8F0"/>
+            </a:solidFill>
+          </a:ln>
+        </p:spPr>
+        <p:style>
+          <a:lnRef idx="1">
+            <a:schemeClr val="accent1"/>
+          </a:lnRef>
+          <a:fillRef idx="3">
+            <a:schemeClr val="accent1"/>
+          </a:fillRef>
+          <a:effectRef idx="2">
+            <a:schemeClr val="accent1"/>
+          </a:effectRef>
+          <a:fontRef idx="minor">
+            <a:schemeClr val="lt1"/>
+          </a:fontRef>
+        </p:style>
+        <p:txBody>
+          <a:bodyPr rtlCol="0" anchor="ctr" wrap="square" lIns="182880" rIns="182880" tIns="164592"/>
+          <a:lstStyle/>
+          <a:p>
+            <a:pPr algn="ctr">
+              <a:spcAft>
+                <a:spcPts val="1000"/>
+              </a:spcAft>
+              <a:defRPr sz="1200" b="1">
+                <a:solidFill>
+                  <a:srgbClr val="1A365D"/>
+                </a:solidFill>
+                <a:latin typeface="Calibri"/>
+              </a:defRPr>
+            </a:pPr>
+            <a:r>
+              <a:t>1. Multi-Tier Subsystem Decomposition</a:t>
+            </a:r>
+          </a:p>
+          <a:p>
+            <a:pPr>
+              <a:lnSpc>
+                <a:spcPct val="115000"/>
+              </a:lnSpc>
+              <a:spcAft>
+                <a:spcPts val="800"/>
+              </a:spcAft>
+              <a:defRPr sz="950">
+                <a:latin typeface="Calibri"/>
+              </a:defRPr>
+            </a:pPr>
+            <a:r>
+              <a:rPr b="1">
+                <a:solidFill>
+                  <a:srgbClr val="0F172A"/>
+                </a:solidFill>
+              </a:rPr>
+              <a:t>Presentation Layer: </a:t>
+            </a:r>
+            <a:r>
+              <a:rPr>
+                <a:solidFill>
+                  <a:srgbClr val="334155"/>
+                </a:solidFill>
+              </a:rPr>
+              <a:t>React 18.3 + Vite 6.1 SPA with dual persona views (Participant Portal &amp; Organizer SaaS Dashboard). 6-tier Poppins typography (weights 300 to 900).</a:t>
+            </a:r>
+          </a:p>
+          <a:p>
+            <a:pPr>
+              <a:lnSpc>
+                <a:spcPct val="115000"/>
+              </a:lnSpc>
+              <a:spcAft>
+                <a:spcPts val="800"/>
+              </a:spcAft>
+              <a:defRPr sz="950">
+                <a:latin typeface="Calibri"/>
+              </a:defRPr>
+            </a:pPr>
+            <a:r>
+              <a:rPr b="1">
+                <a:solidFill>
+                  <a:srgbClr val="0F172A"/>
+                </a:solidFill>
+              </a:rPr>
+              <a:t>API Gateway &amp; Services: </a:t>
+            </a:r>
+            <a:r>
+              <a:rPr>
+                <a:solidFill>
+                  <a:srgbClr val="334155"/>
+                </a:solidFill>
+              </a:rPr>
+              <a:t>FastAPI ASGI server with modular APIRouters (/events, /registrations, /attendance, /stats). Runtime Pydantic v2 schema validations.</a:t>
+            </a:r>
+          </a:p>
+          <a:p>
+            <a:pPr>
+              <a:lnSpc>
+                <a:spcPct val="115000"/>
+              </a:lnSpc>
+              <a:spcAft>
+                <a:spcPts val="800"/>
+              </a:spcAft>
+              <a:defRPr sz="950">
+                <a:latin typeface="Calibri"/>
+              </a:defRPr>
+            </a:pPr>
+            <a:r>
+              <a:rPr b="1">
+                <a:solidFill>
+                  <a:srgbClr val="0F172A"/>
+                </a:solidFill>
+              </a:rPr>
+              <a:t>Dual-Mode Persistence: </a:t>
+            </a:r>
+            <a:r>
+              <a:rPr>
+                <a:solidFill>
+                  <a:srgbClr val="334155"/>
+                </a:solidFill>
+              </a:rPr>
+              <a:t>Unified API service (api.js) probes Supabase Cloud PostgreSQL with RLS. Automatically fails over to local SQLite WAL mode if offline.</a:t>
+            </a:r>
+          </a:p>
+          <a:p>
+            <a:pPr>
+              <a:lnSpc>
+                <a:spcPct val="115000"/>
+              </a:lnSpc>
+              <a:spcAft>
+                <a:spcPts val="800"/>
+              </a:spcAft>
+              <a:defRPr sz="950">
+                <a:latin typeface="Calibri"/>
+              </a:defRPr>
+            </a:pPr>
+            <a:r>
+              <a:rPr b="1">
+                <a:solidFill>
+                  <a:srgbClr val="0F172A"/>
+                </a:solidFill>
+              </a:rPr>
+              <a:t>Client Utilities: </a:t>
+            </a:r>
+            <a:r>
+              <a:rPr>
+                <a:solidFill>
+                  <a:srgbClr val="334155"/>
+                </a:solidFill>
+              </a:rPr>
+              <a:t>Client-side HTML5 canvas QR code ticketing, multi-round session timelines, and UTF-8 CSV roster streaming.</a:t>
+            </a:r>
+          </a:p>
+        </p:txBody>
+      </p:sp>
+      <p:sp>
+        <p:nvSpPr>
+          <p:cNvPr id="8" name="Rectangle 7"/>
+          <p:cNvSpPr/>
+          <p:nvPr/>
+        </p:nvSpPr>
+        <p:spPr>
+          <a:xfrm>
+            <a:off x="731520" y="1874519"/>
+            <a:ext cx="3410712" cy="91440"/>
+          </a:xfrm>
+          <a:prstGeom prst="rect">
+            <a:avLst/>
+          </a:prstGeom>
+          <a:solidFill>
+            <a:srgbClr val="2563EB"/>
+          </a:solidFill>
+          <a:ln>
+            <a:noFill/>
+          </a:ln>
+        </p:spPr>
+        <p:style>
+          <a:lnRef idx="1">
+            <a:schemeClr val="accent1"/>
+          </a:lnRef>
+          <a:fillRef idx="3">
+            <a:schemeClr val="accent1"/>
+          </a:fillRef>
+          <a:effectRef idx="2">
+            <a:schemeClr val="accent1"/>
+          </a:effectRef>
+          <a:fontRef idx="minor">
+            <a:schemeClr val="lt1"/>
+          </a:fontRef>
+        </p:style>
+        <p:txBody>
+          <a:bodyPr rtlCol="0" anchor="ctr"/>
+          <a:lstStyle/>
+          <a:p>
+            <a:pPr algn="ctr"/>
+          </a:p>
+        </p:txBody>
+      </p:sp>
+      <p:sp>
+        <p:nvSpPr>
+          <p:cNvPr id="9" name="Rounded Rectangle 8"/>
+          <p:cNvSpPr/>
+          <p:nvPr/>
+        </p:nvSpPr>
+        <p:spPr>
+          <a:xfrm>
+            <a:off x="4389120" y="1874519"/>
+            <a:ext cx="3410712" cy="4297680"/>
+          </a:xfrm>
+          <a:prstGeom prst="roundRect">
+            <a:avLst/>
+          </a:prstGeom>
+          <a:solidFill>
+            <a:srgbClr val="F8FAFC"/>
+          </a:solidFill>
+          <a:ln w="12700">
+            <a:solidFill>
+              <a:srgbClr val="E2E8F0"/>
+            </a:solidFill>
+          </a:ln>
+        </p:spPr>
+        <p:style>
+          <a:lnRef idx="1">
+            <a:schemeClr val="accent1"/>
+          </a:lnRef>
+          <a:fillRef idx="3">
+            <a:schemeClr val="accent1"/>
+          </a:fillRef>
+          <a:effectRef idx="2">
+            <a:schemeClr val="accent1"/>
+          </a:effectRef>
+          <a:fontRef idx="minor">
+            <a:schemeClr val="lt1"/>
+          </a:fontRef>
+        </p:style>
+        <p:txBody>
+          <a:bodyPr rtlCol="0" anchor="ctr" wrap="square" lIns="182880" rIns="182880" tIns="164592"/>
+          <a:lstStyle/>
+          <a:p>
+            <a:pPr algn="ctr">
+              <a:spcAft>
+                <a:spcPts val="1000"/>
+              </a:spcAft>
+              <a:defRPr sz="1200" b="1">
+                <a:solidFill>
+                  <a:srgbClr val="1A365D"/>
+                </a:solidFill>
+                <a:latin typeface="Calibri"/>
+              </a:defRPr>
+            </a:pPr>
+            <a:r>
+              <a:t>2. Algorithmic Interval Scheduling Engine</a:t>
+            </a:r>
+          </a:p>
+          <a:p>
+            <a:pPr>
+              <a:lnSpc>
+                <a:spcPct val="115000"/>
+              </a:lnSpc>
+              <a:spcAft>
+                <a:spcPts val="800"/>
+              </a:spcAft>
+              <a:defRPr sz="950">
+                <a:latin typeface="Calibri"/>
+              </a:defRPr>
+            </a:pPr>
+            <a:r>
+              <a:rPr b="1">
+                <a:solidFill>
+                  <a:srgbClr val="0F172A"/>
+                </a:solidFill>
+              </a:rPr>
+              <a:t>Discrete Representation: </a:t>
+            </a:r>
+            <a:r>
+              <a:rPr>
+                <a:solidFill>
+                  <a:srgbClr val="334155"/>
+                </a:solidFill>
+              </a:rPr>
+              <a:t>Every booking request is formulated as formal half-open interval I_i = [s_i, e_i) on venue V_k mapped to integer minutes t in [0, 1440).</a:t>
+            </a:r>
+          </a:p>
+          <a:p>
+            <a:pPr>
+              <a:lnSpc>
+                <a:spcPct val="115000"/>
+              </a:lnSpc>
+              <a:spcAft>
+                <a:spcPts val="800"/>
+              </a:spcAft>
+              <a:defRPr sz="950">
+                <a:latin typeface="Calibri"/>
+              </a:defRPr>
+            </a:pPr>
+            <a:r>
+              <a:rPr b="1">
+                <a:solidFill>
+                  <a:srgbClr val="0F172A"/>
+                </a:solidFill>
+              </a:rPr>
+              <a:t>Bisection Search O(log N): </a:t>
+            </a:r>
+            <a:r>
+              <a:rPr>
+                <a:solidFill>
+                  <a:srgbClr val="334155"/>
+                </a:solidFill>
+              </a:rPr>
+              <a:t>Active confirmed venue bookings kept sorted by start time. Bisect locates insertion index in logarithmic O(log N) time.</a:t>
+            </a:r>
+          </a:p>
+          <a:p>
+            <a:pPr>
+              <a:lnSpc>
+                <a:spcPct val="115000"/>
+              </a:lnSpc>
+              <a:spcAft>
+                <a:spcPts val="800"/>
+              </a:spcAft>
+              <a:defRPr sz="950">
+                <a:latin typeface="Calibri"/>
+              </a:defRPr>
+            </a:pPr>
+            <a:r>
+              <a:rPr b="1">
+                <a:solidFill>
+                  <a:srgbClr val="0F172A"/>
+                </a:solidFill>
+              </a:rPr>
+              <a:t>Neighbor-Only Verification: </a:t>
+            </a:r>
+            <a:r>
+              <a:rPr>
+                <a:solidFill>
+                  <a:srgbClr val="334155"/>
+                </a:solidFill>
+              </a:rPr>
+              <a:t>Collision evaluated strictly against adjacent predecessor and successor: (s_new &lt; e_ext) AND (e_new &gt; s_ext). Eliminates O(N) table scans.</a:t>
+            </a:r>
+          </a:p>
+          <a:p>
+            <a:pPr>
+              <a:lnSpc>
+                <a:spcPct val="115000"/>
+              </a:lnSpc>
+              <a:spcAft>
+                <a:spcPts val="800"/>
+              </a:spcAft>
+              <a:defRPr sz="950">
+                <a:latin typeface="Calibri"/>
+              </a:defRPr>
+            </a:pPr>
+            <a:r>
+              <a:rPr b="1">
+                <a:solidFill>
+                  <a:srgbClr val="0F172A"/>
+                </a:solidFill>
+              </a:rPr>
+              <a:t>Batch Optimization (Greedy EFT): </a:t>
+            </a:r>
+            <a:r>
+              <a:rPr>
+                <a:solidFill>
+                  <a:srgbClr val="334155"/>
+                </a:solidFill>
+              </a:rPr>
+              <a:t>Competing reservation batches sorted by finish time (e_1 &lt;= e_2 &lt;= ... &lt;= e_M). Provably optimal throughput in O(M log M).</a:t>
+            </a:r>
+          </a:p>
+        </p:txBody>
+      </p:sp>
+      <p:sp>
+        <p:nvSpPr>
+          <p:cNvPr id="10" name="Rectangle 9"/>
+          <p:cNvSpPr/>
+          <p:nvPr/>
+        </p:nvSpPr>
+        <p:spPr>
+          <a:xfrm>
+            <a:off x="4389120" y="1874519"/>
+            <a:ext cx="3410712" cy="91440"/>
+          </a:xfrm>
+          <a:prstGeom prst="rect">
+            <a:avLst/>
+          </a:prstGeom>
+          <a:solidFill>
+            <a:srgbClr val="1A365D"/>
+          </a:solidFill>
+          <a:ln>
+            <a:noFill/>
+          </a:ln>
+        </p:spPr>
+        <p:style>
+          <a:lnRef idx="1">
+            <a:schemeClr val="accent1"/>
+          </a:lnRef>
+          <a:fillRef idx="3">
+            <a:schemeClr val="accent1"/>
+          </a:fillRef>
+          <a:effectRef idx="2">
+            <a:schemeClr val="accent1"/>
+          </a:effectRef>
+          <a:fontRef idx="minor">
+            <a:schemeClr val="lt1"/>
+          </a:fontRef>
+        </p:style>
+        <p:txBody>
+          <a:bodyPr rtlCol="0" anchor="ctr"/>
+          <a:lstStyle/>
+          <a:p>
+            <a:pPr algn="ctr"/>
+          </a:p>
+        </p:txBody>
+      </p:sp>
+      <p:sp>
+        <p:nvSpPr>
+          <p:cNvPr id="11" name="Rounded Rectangle 10"/>
+          <p:cNvSpPr/>
+          <p:nvPr/>
+        </p:nvSpPr>
+        <p:spPr>
+          <a:xfrm>
+            <a:off x="8046720" y="1874519"/>
+            <a:ext cx="3410712" cy="4297680"/>
+          </a:xfrm>
+          <a:prstGeom prst="roundRect">
+            <a:avLst/>
+          </a:prstGeom>
+          <a:solidFill>
+            <a:srgbClr val="F8FAFC"/>
+          </a:solidFill>
+          <a:ln w="12700">
+            <a:solidFill>
+              <a:srgbClr val="E2E8F0"/>
+            </a:solidFill>
+          </a:ln>
+        </p:spPr>
+        <p:style>
+          <a:lnRef idx="1">
+            <a:schemeClr val="accent1"/>
+          </a:lnRef>
+          <a:fillRef idx="3">
+            <a:schemeClr val="accent1"/>
+          </a:fillRef>
+          <a:effectRef idx="2">
+            <a:schemeClr val="accent1"/>
+          </a:effectRef>
+          <a:fontRef idx="minor">
+            <a:schemeClr val="lt1"/>
+          </a:fontRef>
+        </p:style>
+        <p:txBody>
+          <a:bodyPr rtlCol="0" anchor="ctr" wrap="square" lIns="182880" rIns="182880" tIns="164592"/>
+          <a:lstStyle/>
+          <a:p>
+            <a:pPr algn="ctr">
+              <a:spcAft>
+                <a:spcPts val="1000"/>
+              </a:spcAft>
+              <a:defRPr sz="1200" b="1">
+                <a:solidFill>
+                  <a:srgbClr val="1A365D"/>
+                </a:solidFill>
+                <a:latin typeface="Calibri"/>
+              </a:defRPr>
+            </a:pPr>
+            <a:r>
+              <a:t>3. Concurrency Control &amp; Database Schema</a:t>
+            </a:r>
+          </a:p>
+          <a:p>
+            <a:pPr>
+              <a:lnSpc>
+                <a:spcPct val="115000"/>
+              </a:lnSpc>
+              <a:spcAft>
+                <a:spcPts val="800"/>
+              </a:spcAft>
+              <a:defRPr sz="950">
+                <a:latin typeface="Calibri"/>
+              </a:defRPr>
+            </a:pPr>
+            <a:r>
+              <a:rPr b="1">
+                <a:solidFill>
+                  <a:srgbClr val="0F172A"/>
+                </a:solidFill>
+              </a:rPr>
+              <a:t>ACID Transaction Envelope: </a:t>
+            </a:r>
+            <a:r>
+              <a:rPr>
+                <a:solidFill>
+                  <a:srgbClr val="334155"/>
+                </a:solidFill>
+              </a:rPr>
+              <a:t>Wraps availability read and write inside atomic transaction (BEGIN IMMEDIATE in SQLite; row locks in PostgreSQL) to eliminate TOCTOU race conditions.</a:t>
+            </a:r>
+          </a:p>
+          <a:p>
+            <a:pPr>
+              <a:lnSpc>
+                <a:spcPct val="115000"/>
+              </a:lnSpc>
+              <a:spcAft>
+                <a:spcPts val="800"/>
+              </a:spcAft>
+              <a:defRPr sz="950">
+                <a:latin typeface="Calibri"/>
+              </a:defRPr>
+            </a:pPr>
+            <a:r>
+              <a:rPr b="1">
+                <a:solidFill>
+                  <a:srgbClr val="0F172A"/>
+                </a:solidFill>
+              </a:rPr>
+              <a:t>Venue Mutex Serialization: </a:t>
+            </a:r>
+            <a:r>
+              <a:rPr>
+                <a:solidFill>
+                  <a:srgbClr val="334155"/>
+                </a:solidFill>
+              </a:rPr>
+              <a:t>Simultaneous parallel submissions for the exact same hall serialize at the transaction lock. Only the first commit succeeds.</a:t>
+            </a:r>
+          </a:p>
+          <a:p>
+            <a:pPr>
+              <a:lnSpc>
+                <a:spcPct val="115000"/>
+              </a:lnSpc>
+              <a:spcAft>
+                <a:spcPts val="800"/>
+              </a:spcAft>
+              <a:defRPr sz="950">
+                <a:latin typeface="Calibri"/>
+              </a:defRPr>
+            </a:pPr>
+            <a:r>
+              <a:rPr b="1">
+                <a:solidFill>
+                  <a:srgbClr val="0F172A"/>
+                </a:solidFill>
+              </a:rPr>
+              <a:t>Relational ER Model (6 Tables): </a:t>
+            </a:r>
+            <a:r>
+              <a:rPr>
+                <a:solidFill>
+                  <a:srgbClr val="334155"/>
+                </a:solidFill>
+              </a:rPr>
+              <a:t>organizers (1) -&gt; events (N) -&gt; event_sessions (N) [Cascade]. events (1) -&gt; registrations (N) -&gt; attendance (1). announcements (N).</a:t>
+            </a:r>
+          </a:p>
+          <a:p>
+            <a:pPr>
+              <a:lnSpc>
+                <a:spcPct val="115000"/>
+              </a:lnSpc>
+              <a:spcAft>
+                <a:spcPts val="800"/>
+              </a:spcAft>
+              <a:defRPr sz="950">
+                <a:latin typeface="Calibri"/>
+              </a:defRPr>
+            </a:pPr>
+            <a:r>
+              <a:rPr b="1">
+                <a:solidFill>
+                  <a:srgbClr val="0F172A"/>
+                </a:solidFill>
+              </a:rPr>
+              <a:t>Integrity &amp; Idempotency: </a:t>
+            </a:r>
+            <a:r>
+              <a:rPr>
+                <a:solidFill>
+                  <a:srgbClr val="334155"/>
+                </a:solidFill>
+              </a:rPr>
+              <a:t>Unique constraints on EVF-2026 ticket passes, automated capacity counter triggers, and foreign key cascade deletion.</a:t>
+            </a:r>
+          </a:p>
+        </p:txBody>
+      </p:sp>
+      <p:sp>
+        <p:nvSpPr>
+          <p:cNvPr id="12" name="Rectangle 11"/>
+          <p:cNvSpPr/>
+          <p:nvPr/>
+        </p:nvSpPr>
+        <p:spPr>
+          <a:xfrm>
+            <a:off x="8046720" y="1874519"/>
+            <a:ext cx="3410712" cy="91440"/>
+          </a:xfrm>
+          <a:prstGeom prst="rect">
+            <a:avLst/>
+          </a:prstGeom>
+          <a:solidFill>
+            <a:srgbClr val="0F172A"/>
+          </a:solidFill>
+          <a:ln>
+            <a:noFill/>
+          </a:ln>
+        </p:spPr>
+        <p:style>
+          <a:lnRef idx="1">
+            <a:schemeClr val="accent1"/>
+          </a:lnRef>
+          <a:fillRef idx="3">
+            <a:schemeClr val="accent1"/>
+          </a:fillRef>
+          <a:effectRef idx="2">
+            <a:schemeClr val="accent1"/>
+          </a:effectRef>
+          <a:fontRef idx="minor">
+            <a:schemeClr val="lt1"/>
+          </a:fontRef>
+        </p:style>
+        <p:txBody>
+          <a:bodyPr rtlCol="0" anchor="ctr"/>
+          <a:lstStyle/>
+          <a:p>
+            <a:pPr algn="ctr"/>
+          </a:p>
+        </p:txBody>
+      </p:sp>
+    </p:spTree>
+  </p:cSld>
+  <p:clrMapOvr>
+    <a:masterClrMapping/>
+  </p:clrMapOvr>
+</p:sld>
+</file>
+
+<file path=ppt/slides/slide11.xml><?xml version="1.0" encoding="utf-8"?>
+<p:sld xmlns:a="http://schemas.openxmlformats.org/drawingml/2006/main" xmlns:p="http://schemas.openxmlformats.org/presentationml/2006/main" xmlns:r="http://schemas.openxmlformats.org/officeDocument/2006/relationships">
+  <p:cSld>
+    <p:spTree>
+      <p:nvGrpSpPr>
+        <p:cNvPr id="1" name=""/>
+        <p:cNvGrpSpPr/>
+        <p:nvPr/>
+      </p:nvGrpSpPr>
+      <p:grpSpPr/>
+      <p:sp>
+        <p:nvSpPr>
+          <p:cNvPr id="2" name="Rounded Rectangle 1"/>
+          <p:cNvSpPr/>
+          <p:nvPr/>
+        </p:nvSpPr>
+        <p:spPr>
+          <a:xfrm>
+            <a:off x="731520" y="411480"/>
+            <a:ext cx="4114800" cy="292608"/>
+          </a:xfrm>
+          <a:prstGeom prst="roundRect">
+            <a:avLst/>
+          </a:prstGeom>
+          <a:solidFill>
+            <a:srgbClr val="EEF2FF"/>
+          </a:solidFill>
+          <a:ln w="12700">
+            <a:solidFill>
+              <a:srgbClr val="C7D2FE"/>
+            </a:solidFill>
+          </a:ln>
+        </p:spPr>
+        <p:style>
+          <a:lnRef idx="1">
+            <a:schemeClr val="accent1"/>
+          </a:lnRef>
+          <a:fillRef idx="3">
+            <a:schemeClr val="accent1"/>
+          </a:fillRef>
+          <a:effectRef idx="2">
+            <a:schemeClr val="accent1"/>
+          </a:effectRef>
+          <a:fontRef idx="minor">
+            <a:schemeClr val="lt1"/>
+          </a:fontRef>
+        </p:style>
+        <p:txBody>
+          <a:bodyPr rtlCol="0" anchor="ctr" wrap="square" lIns="109728" tIns="36576"/>
+          <a:lstStyle/>
+          <a:p>
+            <a:pPr algn="ctr">
+              <a:defRPr sz="950" b="1">
+                <a:solidFill>
+                  <a:srgbClr val="312E81"/>
+                </a:solidFill>
+                <a:latin typeface="Calibri"/>
+              </a:defRPr>
+            </a:pPr>
+            <a:r>
+              <a:t>SOFTWARE ENGINEERING LIFECYCLE | PHASE 3</a:t>
+            </a:r>
+          </a:p>
+        </p:txBody>
+      </p:sp>
+      <p:sp>
+        <p:nvSpPr>
+          <p:cNvPr id="3" name="TextBox 2"/>
+          <p:cNvSpPr txBox="1"/>
+          <p:nvPr/>
+        </p:nvSpPr>
+        <p:spPr>
+          <a:xfrm>
+            <a:off x="731520" y="777240"/>
+            <a:ext cx="10698480" cy="868680"/>
+          </a:xfrm>
+          <a:prstGeom prst="rect">
+            <a:avLst/>
+          </a:prstGeom>
+          <a:noFill/>
+        </p:spPr>
+        <p:txBody>
+          <a:bodyPr wrap="square" lIns="0" tIns="0" rIns="0" bIns="0">
+            <a:spAutoFit/>
+          </a:bodyPr>
+          <a:lstStyle/>
+          <a:p>
+            <a:pPr>
+              <a:defRPr sz="2200" b="1">
+                <a:solidFill>
+                  <a:srgbClr val="1A365D"/>
+                </a:solidFill>
+                <a:latin typeface="Calibri"/>
+              </a:defRPr>
+            </a:pPr>
+            <a:r>
+              <a:t>Module 3: Development Implementation &amp; Test Automation</a:t>
+            </a:r>
+          </a:p>
+          <a:p>
+            <a:pPr>
+              <a:spcBef>
+                <a:spcPts val="300"/>
+              </a:spcBef>
+              <a:defRPr sz="1200">
+                <a:solidFill>
+                  <a:srgbClr val="64748B"/>
+                </a:solidFill>
+                <a:latin typeface="Calibri"/>
+              </a:defRPr>
+            </a:pPr>
+            <a:r>
+              <a:t>Modular full-stack implementation and rigorous 28-suite Pytest verification matrix</a:t>
+            </a:r>
+          </a:p>
+        </p:txBody>
+      </p:sp>
+      <p:sp>
+        <p:nvSpPr>
+          <p:cNvPr id="4" name="Rectangle 3"/>
+          <p:cNvSpPr/>
+          <p:nvPr/>
+        </p:nvSpPr>
+        <p:spPr>
+          <a:xfrm>
+            <a:off x="731520" y="1691640"/>
+            <a:ext cx="10725912" cy="18288"/>
+          </a:xfrm>
+          <a:prstGeom prst="rect">
+            <a:avLst/>
+          </a:prstGeom>
+          <a:solidFill>
+            <a:srgbClr val="E2E8F0"/>
+          </a:solidFill>
+          <a:ln>
+            <a:solidFill>
+              <a:srgbClr val="E2E8F0"/>
+            </a:solidFill>
+          </a:ln>
+        </p:spPr>
+        <p:style>
+          <a:lnRef idx="1">
+            <a:schemeClr val="accent1"/>
+          </a:lnRef>
+          <a:fillRef idx="3">
+            <a:schemeClr val="accent1"/>
+          </a:fillRef>
+          <a:effectRef idx="2">
+            <a:schemeClr val="accent1"/>
+          </a:effectRef>
+          <a:fontRef idx="minor">
+            <a:schemeClr val="lt1"/>
+          </a:fontRef>
+        </p:style>
+        <p:txBody>
+          <a:bodyPr rtlCol="0" anchor="ctr"/>
+          <a:lstStyle/>
+          <a:p>
+            <a:pPr algn="ctr"/>
+          </a:p>
+        </p:txBody>
+      </p:sp>
+      <p:sp>
+        <p:nvSpPr>
+          <p:cNvPr id="5" name="TextBox 4"/>
+          <p:cNvSpPr txBox="1"/>
+          <p:nvPr/>
+        </p:nvSpPr>
+        <p:spPr>
+          <a:xfrm>
+            <a:off x="731520" y="6400800"/>
+            <a:ext cx="7315200" cy="274320"/>
+          </a:xfrm>
+          <a:prstGeom prst="rect">
+            <a:avLst/>
+          </a:prstGeom>
+          <a:noFill/>
+        </p:spPr>
+        <p:txBody>
+          <a:bodyPr wrap="square" lIns="0" tIns="0">
+            <a:spAutoFit/>
+          </a:bodyPr>
+          <a:lstStyle/>
+          <a:p>
+            <a:pPr>
+              <a:defRPr sz="900">
+                <a:solidFill>
+                  <a:srgbClr val="64748B"/>
+                </a:solidFill>
+                <a:latin typeface="Calibri"/>
+              </a:defRPr>
+            </a:pPr>
+            <a:r>
+              <a:t>CSA1021 - Software Engineering | Capstone Project 2026 | Saveetha School of Engineering (SIMATS)</a:t>
+            </a:r>
+          </a:p>
+        </p:txBody>
+      </p:sp>
+      <p:sp>
+        <p:nvSpPr>
+          <p:cNvPr id="6" name="TextBox 5"/>
+          <p:cNvSpPr txBox="1"/>
+          <p:nvPr/>
+        </p:nvSpPr>
+        <p:spPr>
+          <a:xfrm>
+            <a:off x="9601200" y="6400800"/>
+            <a:ext cx="1828800" cy="274320"/>
+          </a:xfrm>
+          <a:prstGeom prst="rect">
+            <a:avLst/>
+          </a:prstGeom>
+          <a:noFill/>
+        </p:spPr>
+        <p:txBody>
+          <a:bodyPr wrap="square" rIns="0" tIns="0">
+            <a:spAutoFit/>
+          </a:bodyPr>
+          <a:lstStyle/>
+          <a:p>
+            <a:pPr algn="r">
+              <a:defRPr sz="900">
+                <a:solidFill>
+                  <a:srgbClr val="64748B"/>
+                </a:solidFill>
+                <a:latin typeface="Calibri"/>
+              </a:defRPr>
+            </a:pPr>
+            <a:r>
+              <a:t>Slide 11 of 13</a:t>
+            </a:r>
+          </a:p>
+        </p:txBody>
+      </p:sp>
+      <p:sp>
+        <p:nvSpPr>
+          <p:cNvPr id="7" name="Rounded Rectangle 6"/>
+          <p:cNvSpPr/>
+          <p:nvPr/>
+        </p:nvSpPr>
+        <p:spPr>
+          <a:xfrm>
+            <a:off x="731520" y="1874519"/>
+            <a:ext cx="5239512" cy="2057400"/>
+          </a:xfrm>
+          <a:prstGeom prst="roundRect">
+            <a:avLst/>
+          </a:prstGeom>
+          <a:solidFill>
+            <a:srgbClr val="F8FAFC"/>
+          </a:solidFill>
+          <a:ln w="12700">
+            <a:solidFill>
+              <a:srgbClr val="E2E8F0"/>
+            </a:solidFill>
+          </a:ln>
+        </p:spPr>
+        <p:style>
+          <a:lnRef idx="1">
+            <a:schemeClr val="accent1"/>
+          </a:lnRef>
+          <a:fillRef idx="3">
+            <a:schemeClr val="accent1"/>
+          </a:fillRef>
+          <a:effectRef idx="2">
+            <a:schemeClr val="accent1"/>
+          </a:effectRef>
+          <a:fontRef idx="minor">
+            <a:schemeClr val="lt1"/>
+          </a:fontRef>
+        </p:style>
+        <p:txBody>
+          <a:bodyPr rtlCol="0" anchor="ctr" wrap="square" lIns="274320" tIns="164592" rIns="182880"/>
+          <a:lstStyle/>
+          <a:p>
+            <a:pPr algn="ctr">
+              <a:spcAft>
+                <a:spcPts val="600"/>
+              </a:spcAft>
+              <a:defRPr sz="1250" b="1">
+                <a:solidFill>
+                  <a:srgbClr val="1A365D"/>
+                </a:solidFill>
+                <a:latin typeface="Calibri"/>
+              </a:defRPr>
+            </a:pPr>
+            <a:r>
+              <a:t>1. Full-Stack Implementation Stack</a:t>
+            </a:r>
+          </a:p>
+          <a:p>
+            <a:pPr>
+              <a:lnSpc>
+                <a:spcPct val="118000"/>
+              </a:lnSpc>
+              <a:defRPr sz="950">
+                <a:solidFill>
+                  <a:srgbClr val="334155"/>
+                </a:solidFill>
+                <a:latin typeface="Calibri"/>
+              </a:defRPr>
+            </a:pPr>
+            <a:r>
+              <a:t>FastAPI Asynchronous Engine: Type-safe APIRouters with Pydantic v2 schemas; connection pooling context manager (@contextmanager get_db()) with Write-Ahead Logging.</a:t>
+            </a:r>
+            <a:br/>
+            <a:r>
+              <a:t>React 18.3 Client: Single Page Application built with Vite 6.1; modular EventManager, TicketScannerModal, and AnalyticsOverview.</a:t>
+            </a:r>
+            <a:br/>
+            <a:r>
+              <a:t>Poppins Design Tokens: 6 calibrated weight classes (font-light 300 to font-black 900) mapped in Tailwind CSS for clear visual hierarchy.</a:t>
+            </a:r>
+            <a:br/>
+            <a:r>
+              <a:t>Dual-Mode Bridge: api.js dynamically switches between Supabase Cloud and local FastAPI.</a:t>
+            </a:r>
+          </a:p>
+        </p:txBody>
+      </p:sp>
+      <p:sp>
+        <p:nvSpPr>
+          <p:cNvPr id="8" name="Rectangle 7"/>
+          <p:cNvSpPr/>
+          <p:nvPr/>
+        </p:nvSpPr>
+        <p:spPr>
+          <a:xfrm>
+            <a:off x="731520" y="1874519"/>
+            <a:ext cx="109728" cy="2057400"/>
+          </a:xfrm>
+          <a:prstGeom prst="rect">
+            <a:avLst/>
+          </a:prstGeom>
+          <a:solidFill>
+            <a:srgbClr val="2563EB"/>
+          </a:solidFill>
+          <a:ln>
+            <a:noFill/>
+          </a:ln>
+        </p:spPr>
+        <p:style>
+          <a:lnRef idx="1">
+            <a:schemeClr val="accent1"/>
+          </a:lnRef>
+          <a:fillRef idx="3">
+            <a:schemeClr val="accent1"/>
+          </a:fillRef>
+          <a:effectRef idx="2">
+            <a:schemeClr val="accent1"/>
+          </a:effectRef>
+          <a:fontRef idx="minor">
+            <a:schemeClr val="lt1"/>
+          </a:fontRef>
+        </p:style>
+        <p:txBody>
+          <a:bodyPr rtlCol="0" anchor="ctr"/>
+          <a:lstStyle/>
+          <a:p>
+            <a:pPr algn="ctr"/>
+          </a:p>
+        </p:txBody>
+      </p:sp>
+      <p:sp>
+        <p:nvSpPr>
+          <p:cNvPr id="9" name="Rounded Rectangle 8"/>
+          <p:cNvSpPr/>
+          <p:nvPr/>
+        </p:nvSpPr>
+        <p:spPr>
+          <a:xfrm>
+            <a:off x="731520" y="4114800"/>
+            <a:ext cx="5239512" cy="2057400"/>
+          </a:xfrm>
+          <a:prstGeom prst="roundRect">
+            <a:avLst/>
+          </a:prstGeom>
+          <a:solidFill>
+            <a:srgbClr val="F8FAFC"/>
+          </a:solidFill>
+          <a:ln w="12700">
+            <a:solidFill>
+              <a:srgbClr val="E2E8F0"/>
+            </a:solidFill>
+          </a:ln>
+        </p:spPr>
+        <p:style>
+          <a:lnRef idx="1">
+            <a:schemeClr val="accent1"/>
+          </a:lnRef>
+          <a:fillRef idx="3">
+            <a:schemeClr val="accent1"/>
+          </a:fillRef>
+          <a:effectRef idx="2">
+            <a:schemeClr val="accent1"/>
+          </a:effectRef>
+          <a:fontRef idx="minor">
+            <a:schemeClr val="lt1"/>
+          </a:fontRef>
+        </p:style>
+        <p:txBody>
+          <a:bodyPr rtlCol="0" anchor="ctr" wrap="square" lIns="274320" tIns="164592" rIns="182880"/>
+          <a:lstStyle/>
+          <a:p>
+            <a:pPr algn="ctr">
+              <a:spcAft>
+                <a:spcPts val="600"/>
+              </a:spcAft>
+              <a:defRPr sz="1250" b="1">
+                <a:solidFill>
+                  <a:srgbClr val="1A365D"/>
+                </a:solidFill>
+                <a:latin typeface="Calibri"/>
+              </a:defRPr>
+            </a:pPr>
+            <a:r>
+              <a:t>2. Algorithmic Collision Engine Implementation</a:t>
+            </a:r>
+          </a:p>
+          <a:p>
+            <a:pPr>
+              <a:lnSpc>
+                <a:spcPct val="118000"/>
+              </a:lnSpc>
+              <a:defRPr sz="950">
+                <a:solidFill>
+                  <a:srgbClr val="334155"/>
+                </a:solidFill>
+                <a:latin typeface="Calibri"/>
+              </a:defRPr>
+            </a:pPr>
+            <a:r>
+              <a:t>Time Serialization: Normalizes 12h/24h timestamps into discrete minutes t in [0, 1440).</a:t>
+            </a:r>
+            <a:br/>
+            <a:r>
+              <a:t>Bisection Neighbor Check:</a:t>
+            </a:r>
+            <a:br/>
+            <a:r>
+              <a:t>  idx = bisect.bisect_left([i[0] for i in intervals], s_new)</a:t>
+            </a:r>
+            <a:br/>
+            <a:r>
+              <a:t>  if idx &gt; 0 and intervals[idx-1][1] &gt; s_new: return False (Overlap Predecessor)</a:t>
+            </a:r>
+            <a:br/>
+            <a:r>
+              <a:t>  if idx &lt; len(intervals) and intervals[idx][0] &lt; e_new: return False (Overlap Successor)</a:t>
+            </a:r>
+            <a:br/>
+            <a:r>
+              <a:t>Nearest Slot Discovery: Iterates adjacent gaps [e_{k-1}, s_k) where (s_k - e_{k-1}) &gt;= dt to suggest immediate alternatives.</a:t>
+            </a:r>
+          </a:p>
+        </p:txBody>
+      </p:sp>
+      <p:sp>
+        <p:nvSpPr>
+          <p:cNvPr id="10" name="Rectangle 9"/>
+          <p:cNvSpPr/>
+          <p:nvPr/>
+        </p:nvSpPr>
+        <p:spPr>
+          <a:xfrm>
+            <a:off x="731520" y="4114800"/>
+            <a:ext cx="109728" cy="2057400"/>
+          </a:xfrm>
+          <a:prstGeom prst="rect">
+            <a:avLst/>
+          </a:prstGeom>
+          <a:solidFill>
+            <a:srgbClr val="1A365D"/>
+          </a:solidFill>
+          <a:ln>
+            <a:noFill/>
+          </a:ln>
+        </p:spPr>
+        <p:style>
+          <a:lnRef idx="1">
+            <a:schemeClr val="accent1"/>
+          </a:lnRef>
+          <a:fillRef idx="3">
+            <a:schemeClr val="accent1"/>
+          </a:fillRef>
+          <a:effectRef idx="2">
+            <a:schemeClr val="accent1"/>
+          </a:effectRef>
+          <a:fontRef idx="minor">
+            <a:schemeClr val="lt1"/>
+          </a:fontRef>
+        </p:style>
+        <p:txBody>
+          <a:bodyPr rtlCol="0" anchor="ctr"/>
+          <a:lstStyle/>
+          <a:p>
+            <a:pPr algn="ctr"/>
+          </a:p>
+        </p:txBody>
+      </p:sp>
+      <p:sp>
+        <p:nvSpPr>
+          <p:cNvPr id="11" name="Rounded Rectangle 10"/>
+          <p:cNvSpPr/>
+          <p:nvPr/>
+        </p:nvSpPr>
+        <p:spPr>
+          <a:xfrm>
+            <a:off x="6217920" y="1874519"/>
+            <a:ext cx="5239512" cy="4297680"/>
+          </a:xfrm>
+          <a:prstGeom prst="roundRect">
+            <a:avLst/>
+          </a:prstGeom>
+          <a:solidFill>
+            <a:srgbClr val="F8FAFC"/>
+          </a:solidFill>
+          <a:ln w="12700">
+            <a:solidFill>
+              <a:srgbClr val="E2E8F0"/>
+            </a:solidFill>
+          </a:ln>
+        </p:spPr>
+        <p:style>
+          <a:lnRef idx="1">
+            <a:schemeClr val="accent1"/>
+          </a:lnRef>
+          <a:fillRef idx="3">
+            <a:schemeClr val="accent1"/>
+          </a:fillRef>
+          <a:effectRef idx="2">
+            <a:schemeClr val="accent1"/>
+          </a:effectRef>
+          <a:fontRef idx="minor">
+            <a:schemeClr val="lt1"/>
+          </a:fontRef>
+        </p:style>
+        <p:txBody>
+          <a:bodyPr rtlCol="0" anchor="ctr" wrap="square" lIns="274320" tIns="164592" rIns="182880"/>
+          <a:lstStyle/>
+          <a:p>
+            <a:pPr algn="ctr">
+              <a:spcAft>
+                <a:spcPts val="800"/>
+              </a:spcAft>
+              <a:defRPr sz="1300" b="1">
+                <a:solidFill>
+                  <a:srgbClr val="1A365D"/>
+                </a:solidFill>
+                <a:latin typeface="Calibri"/>
+              </a:defRPr>
+            </a:pPr>
+            <a:r>
+              <a:t>3. Automated Pytest Verification Matrix (28 Tests Passed)</a:t>
+            </a:r>
+          </a:p>
+          <a:p>
+            <a:pPr>
+              <a:lnSpc>
+                <a:spcPct val="115000"/>
+              </a:lnSpc>
+              <a:spcAft>
+                <a:spcPts val="400"/>
+              </a:spcAft>
+              <a:defRPr sz="950">
+                <a:latin typeface="Calibri"/>
+              </a:defRPr>
+            </a:pPr>
+            <a:r>
+              <a:rPr b="1">
+                <a:solidFill>
+                  <a:srgbClr val="0F172A"/>
+                </a:solidFill>
+              </a:rPr>
+              <a:t>test_events.py (5 Tests | PASSED): </a:t>
+            </a:r>
+            <a:r>
+              <a:rPr>
+                <a:solidFill>
+                  <a:srgbClr val="334155"/>
+                </a:solidFill>
+              </a:rPr>
+              <a:t>Event creation, nested session ordering, update, search filters, and cascading relational deletion.</a:t>
+            </a:r>
+          </a:p>
+          <a:p>
+            <a:pPr>
+              <a:lnSpc>
+                <a:spcPct val="115000"/>
+              </a:lnSpc>
+              <a:spcAft>
+                <a:spcPts val="400"/>
+              </a:spcAft>
+              <a:defRPr sz="950">
+                <a:latin typeface="Calibri"/>
+              </a:defRPr>
+            </a:pPr>
+            <a:r>
+              <a:rPr b="1">
+                <a:solidFill>
+                  <a:srgbClr val="0F172A"/>
+                </a:solidFill>
+              </a:rPr>
+              <a:t>test_registrations.py (5 Tests | PASSED): </a:t>
+            </a:r>
+            <a:r>
+              <a:rPr>
+                <a:solidFill>
+                  <a:srgbClr val="334155"/>
+                </a:solidFill>
+              </a:rPr>
+              <a:t>Successful registration, duplicate email rejection (409 Conflict), capacity cap overflow (400), and UTF-8 CSV roster exports.</a:t>
+            </a:r>
+          </a:p>
+          <a:p>
+            <a:pPr>
+              <a:lnSpc>
+                <a:spcPct val="115000"/>
+              </a:lnSpc>
+              <a:spcAft>
+                <a:spcPts val="400"/>
+              </a:spcAft>
+              <a:defRPr sz="950">
+                <a:latin typeface="Calibri"/>
+              </a:defRPr>
+            </a:pPr>
+            <a:r>
+              <a:rPr b="1">
+                <a:solidFill>
+                  <a:srgbClr val="0F172A"/>
+                </a:solidFill>
+              </a:rPr>
+              <a:t>test_attendance.py (3 Tests | PASSED): </a:t>
+            </a:r>
+            <a:r>
+              <a:rPr>
+                <a:solidFill>
+                  <a:srgbClr val="334155"/>
+                </a:solidFill>
+              </a:rPr>
+              <a:t>EVF-2026 ticket code verification, automatic check-in toggle, and invalid status rejection.</a:t>
+            </a:r>
+          </a:p>
+          <a:p>
+            <a:pPr>
+              <a:lnSpc>
+                <a:spcPct val="115000"/>
+              </a:lnSpc>
+              <a:spcAft>
+                <a:spcPts val="400"/>
+              </a:spcAft>
+              <a:defRPr sz="950">
+                <a:latin typeface="Calibri"/>
+              </a:defRPr>
+            </a:pPr>
+            <a:r>
+              <a:rPr b="1">
+                <a:solidFill>
+                  <a:srgbClr val="0F172A"/>
+                </a:solidFill>
+              </a:rPr>
+              <a:t>test_database.py (4 Tests | PASSED): </a:t>
+            </a:r>
+            <a:r>
+              <a:rPr>
+                <a:solidFill>
+                  <a:srgbClr val="334155"/>
+                </a:solidFill>
+              </a:rPr>
+              <a:t>Schema migration, WAL mode verification, foreign key constraints, and atomic rollback on simulated database faults.</a:t>
+            </a:r>
+          </a:p>
+          <a:p>
+            <a:pPr>
+              <a:lnSpc>
+                <a:spcPct val="115000"/>
+              </a:lnSpc>
+              <a:spcAft>
+                <a:spcPts val="400"/>
+              </a:spcAft>
+              <a:defRPr sz="950">
+                <a:latin typeface="Calibri"/>
+              </a:defRPr>
+            </a:pPr>
+            <a:r>
+              <a:rPr b="1">
+                <a:solidFill>
+                  <a:srgbClr val="0F172A"/>
+                </a:solidFill>
+              </a:rPr>
+              <a:t>test_stats_announcements.py (5 Tests | PASSED): </a:t>
+            </a:r>
+            <a:r>
+              <a:rPr>
+                <a:solidFill>
+                  <a:srgbClr val="334155"/>
+                </a:solidFill>
+              </a:rPr>
+              <a:t>Platform KPI aggregations, department breakdown, category counts, and priority broadcast management.</a:t>
+            </a:r>
+          </a:p>
+          <a:p>
+            <a:pPr>
+              <a:lnSpc>
+                <a:spcPct val="115000"/>
+              </a:lnSpc>
+              <a:spcAft>
+                <a:spcPts val="400"/>
+              </a:spcAft>
+              <a:defRPr sz="950">
+                <a:latin typeface="Calibri"/>
+              </a:defRPr>
+            </a:pPr>
+            <a:r>
+              <a:rPr b="1">
+                <a:solidFill>
+                  <a:srgbClr val="0F172A"/>
+                </a:solidFill>
+              </a:rPr>
+              <a:t>test_api.py &amp; test_health.py (6 Tests | PASSED): </a:t>
+            </a:r>
+            <a:r>
+              <a:rPr>
+                <a:solidFill>
+                  <a:srgbClr val="334155"/>
+                </a:solidFill>
+              </a:rPr>
+              <a:t>End-to-end integration workflow from event creation through ticket scanning; service liveness probe.</a:t>
+            </a:r>
+          </a:p>
+          <a:p>
+            <a:pPr>
+              <a:spcBef>
+                <a:spcPts val="800"/>
+              </a:spcBef>
+              <a:defRPr sz="1000" b="1">
+                <a:solidFill>
+                  <a:srgbClr val="10B981"/>
+                </a:solidFill>
+                <a:latin typeface="Calibri"/>
+              </a:defRPr>
+            </a:pPr>
+            <a:r>
+              <a:t>Execution Verdict: 28 Passed in 0.71s (100% Pass Rate, 0 Regressions, Clean Build)</a:t>
+            </a:r>
+          </a:p>
+        </p:txBody>
+      </p:sp>
+      <p:sp>
+        <p:nvSpPr>
+          <p:cNvPr id="12" name="Rectangle 11"/>
+          <p:cNvSpPr/>
+          <p:nvPr/>
+        </p:nvSpPr>
+        <p:spPr>
+          <a:xfrm>
+            <a:off x="6217920" y="1874519"/>
+            <a:ext cx="109728" cy="4297680"/>
+          </a:xfrm>
+          <a:prstGeom prst="rect">
+            <a:avLst/>
+          </a:prstGeom>
+          <a:solidFill>
+            <a:srgbClr val="10B981"/>
+          </a:solidFill>
+          <a:ln>
+            <a:noFill/>
+          </a:ln>
+        </p:spPr>
+        <p:style>
+          <a:lnRef idx="1">
+            <a:schemeClr val="accent1"/>
+          </a:lnRef>
+          <a:fillRef idx="3">
+            <a:schemeClr val="accent1"/>
+          </a:fillRef>
+          <a:effectRef idx="2">
+            <a:schemeClr val="accent1"/>
+          </a:effectRef>
+          <a:fontRef idx="minor">
+            <a:schemeClr val="lt1"/>
+          </a:fontRef>
+        </p:style>
+        <p:txBody>
+          <a:bodyPr rtlCol="0" anchor="ctr"/>
+          <a:lstStyle/>
+          <a:p>
+            <a:pPr algn="ctr"/>
+          </a:p>
+        </p:txBody>
+      </p:sp>
+    </p:spTree>
+  </p:cSld>
+  <p:clrMapOvr>
+    <a:masterClrMapping/>
+  </p:clrMapOvr>
+</p:sld>
+</file>
+
+<file path=ppt/slides/slide12.xml><?xml version="1.0" encoding="utf-8"?>
+<p:sld xmlns:a="http://schemas.openxmlformats.org/drawingml/2006/main" xmlns:p="http://schemas.openxmlformats.org/presentationml/2006/main" xmlns:r="http://schemas.openxmlformats.org/officeDocument/2006/relationships">
+  <p:cSld>
+    <p:spTree>
+      <p:nvGrpSpPr>
+        <p:cNvPr id="1" name=""/>
+        <p:cNvGrpSpPr/>
+        <p:nvPr/>
+      </p:nvGrpSpPr>
+      <p:grpSpPr/>
+      <p:sp>
+        <p:nvSpPr>
+          <p:cNvPr id="2" name="Rounded Rectangle 1"/>
+          <p:cNvSpPr/>
+          <p:nvPr/>
+        </p:nvSpPr>
+        <p:spPr>
+          <a:xfrm>
+            <a:off x="731520" y="411480"/>
+            <a:ext cx="4114800" cy="292608"/>
+          </a:xfrm>
+          <a:prstGeom prst="roundRect">
+            <a:avLst/>
+          </a:prstGeom>
+          <a:solidFill>
+            <a:srgbClr val="EEF2FF"/>
+          </a:solidFill>
+          <a:ln w="12700">
+            <a:solidFill>
+              <a:srgbClr val="C7D2FE"/>
+            </a:solidFill>
+          </a:ln>
+        </p:spPr>
+        <p:style>
+          <a:lnRef idx="1">
+            <a:schemeClr val="accent1"/>
+          </a:lnRef>
+          <a:fillRef idx="3">
+            <a:schemeClr val="accent1"/>
+          </a:fillRef>
+          <a:effectRef idx="2">
+            <a:schemeClr val="accent1"/>
+          </a:effectRef>
+          <a:fontRef idx="minor">
+            <a:schemeClr val="lt1"/>
+          </a:fontRef>
+        </p:style>
+        <p:txBody>
+          <a:bodyPr rtlCol="0" anchor="ctr" wrap="square" lIns="109728" tIns="36576"/>
+          <a:lstStyle/>
+          <a:p>
+            <a:pPr algn="ctr">
+              <a:defRPr sz="950" b="1">
+                <a:solidFill>
+                  <a:srgbClr val="312E81"/>
+                </a:solidFill>
+                <a:latin typeface="Calibri"/>
+              </a:defRPr>
+            </a:pPr>
+            <a:r>
+              <a:t>SOFTWARE ENGINEERING LIFECYCLE | PHASE 4</a:t>
+            </a:r>
+          </a:p>
+        </p:txBody>
+      </p:sp>
+      <p:sp>
+        <p:nvSpPr>
+          <p:cNvPr id="3" name="TextBox 2"/>
+          <p:cNvSpPr txBox="1"/>
+          <p:nvPr/>
+        </p:nvSpPr>
+        <p:spPr>
+          <a:xfrm>
+            <a:off x="731520" y="777240"/>
+            <a:ext cx="10698480" cy="868680"/>
+          </a:xfrm>
+          <a:prstGeom prst="rect">
+            <a:avLst/>
+          </a:prstGeom>
+          <a:noFill/>
+        </p:spPr>
+        <p:txBody>
+          <a:bodyPr wrap="square" lIns="0" tIns="0" rIns="0" bIns="0">
+            <a:spAutoFit/>
+          </a:bodyPr>
+          <a:lstStyle/>
+          <a:p>
+            <a:pPr>
+              <a:defRPr sz="2200" b="1">
+                <a:solidFill>
+                  <a:srgbClr val="1A365D"/>
+                </a:solidFill>
+                <a:latin typeface="Calibri"/>
+              </a:defRPr>
+            </a:pPr>
+            <a:r>
+              <a:t>Module 4: Deployment Architecture &amp; DevOps Engineering</a:t>
+            </a:r>
+          </a:p>
+          <a:p>
+            <a:pPr>
+              <a:spcBef>
+                <a:spcPts val="300"/>
+              </a:spcBef>
+              <a:defRPr sz="1200">
+                <a:solidFill>
+                  <a:srgbClr val="64748B"/>
+                </a:solidFill>
+                <a:latin typeface="Calibri"/>
+              </a:defRPr>
+            </a:pPr>
+            <a:r>
+              <a:t>Dual-mode deployment topology, CI/CD automation pipeline, and production security hardening</a:t>
+            </a:r>
+          </a:p>
+        </p:txBody>
+      </p:sp>
+      <p:sp>
+        <p:nvSpPr>
+          <p:cNvPr id="4" name="Rectangle 3"/>
+          <p:cNvSpPr/>
+          <p:nvPr/>
+        </p:nvSpPr>
+        <p:spPr>
+          <a:xfrm>
+            <a:off x="731520" y="1691640"/>
+            <a:ext cx="10725912" cy="18288"/>
+          </a:xfrm>
+          <a:prstGeom prst="rect">
+            <a:avLst/>
+          </a:prstGeom>
+          <a:solidFill>
+            <a:srgbClr val="E2E8F0"/>
+          </a:solidFill>
+          <a:ln>
+            <a:solidFill>
+              <a:srgbClr val="E2E8F0"/>
+            </a:solidFill>
+          </a:ln>
+        </p:spPr>
+        <p:style>
+          <a:lnRef idx="1">
+            <a:schemeClr val="accent1"/>
+          </a:lnRef>
+          <a:fillRef idx="3">
+            <a:schemeClr val="accent1"/>
+          </a:fillRef>
+          <a:effectRef idx="2">
+            <a:schemeClr val="accent1"/>
+          </a:effectRef>
+          <a:fontRef idx="minor">
+            <a:schemeClr val="lt1"/>
+          </a:fontRef>
+        </p:style>
+        <p:txBody>
+          <a:bodyPr rtlCol="0" anchor="ctr"/>
+          <a:lstStyle/>
+          <a:p>
+            <a:pPr algn="ctr"/>
+          </a:p>
+        </p:txBody>
+      </p:sp>
+      <p:sp>
+        <p:nvSpPr>
+          <p:cNvPr id="5" name="TextBox 4"/>
+          <p:cNvSpPr txBox="1"/>
+          <p:nvPr/>
+        </p:nvSpPr>
+        <p:spPr>
+          <a:xfrm>
+            <a:off x="731520" y="6400800"/>
+            <a:ext cx="7315200" cy="274320"/>
+          </a:xfrm>
+          <a:prstGeom prst="rect">
+            <a:avLst/>
+          </a:prstGeom>
+          <a:noFill/>
+        </p:spPr>
+        <p:txBody>
+          <a:bodyPr wrap="square" lIns="0" tIns="0">
+            <a:spAutoFit/>
+          </a:bodyPr>
+          <a:lstStyle/>
+          <a:p>
+            <a:pPr>
+              <a:defRPr sz="900">
+                <a:solidFill>
+                  <a:srgbClr val="64748B"/>
+                </a:solidFill>
+                <a:latin typeface="Calibri"/>
+              </a:defRPr>
+            </a:pPr>
+            <a:r>
+              <a:t>CSA1021 - Software Engineering | Capstone Project 2026 | Saveetha School of Engineering (SIMATS)</a:t>
+            </a:r>
+          </a:p>
+        </p:txBody>
+      </p:sp>
+      <p:sp>
+        <p:nvSpPr>
+          <p:cNvPr id="6" name="TextBox 5"/>
+          <p:cNvSpPr txBox="1"/>
+          <p:nvPr/>
+        </p:nvSpPr>
+        <p:spPr>
+          <a:xfrm>
+            <a:off x="9601200" y="6400800"/>
+            <a:ext cx="1828800" cy="274320"/>
+          </a:xfrm>
+          <a:prstGeom prst="rect">
+            <a:avLst/>
+          </a:prstGeom>
+          <a:noFill/>
+        </p:spPr>
+        <p:txBody>
+          <a:bodyPr wrap="square" rIns="0" tIns="0">
+            <a:spAutoFit/>
+          </a:bodyPr>
+          <a:lstStyle/>
+          <a:p>
+            <a:pPr algn="r">
+              <a:defRPr sz="900">
+                <a:solidFill>
+                  <a:srgbClr val="64748B"/>
+                </a:solidFill>
+                <a:latin typeface="Calibri"/>
+              </a:defRPr>
+            </a:pPr>
+            <a:r>
+              <a:t>Slide 12 of 13</a:t>
+            </a:r>
+          </a:p>
+        </p:txBody>
+      </p:sp>
+      <p:sp>
+        <p:nvSpPr>
+          <p:cNvPr id="7" name="Rounded Rectangle 6"/>
+          <p:cNvSpPr/>
+          <p:nvPr/>
+        </p:nvSpPr>
+        <p:spPr>
+          <a:xfrm>
+            <a:off x="731520" y="1874519"/>
+            <a:ext cx="3410712" cy="4297680"/>
+          </a:xfrm>
+          <a:prstGeom prst="roundRect">
+            <a:avLst/>
+          </a:prstGeom>
+          <a:solidFill>
+            <a:srgbClr val="F8FAFC"/>
+          </a:solidFill>
+          <a:ln w="12700">
+            <a:solidFill>
+              <a:srgbClr val="E2E8F0"/>
+            </a:solidFill>
+          </a:ln>
+        </p:spPr>
+        <p:style>
+          <a:lnRef idx="1">
+            <a:schemeClr val="accent1"/>
+          </a:lnRef>
+          <a:fillRef idx="3">
+            <a:schemeClr val="accent1"/>
+          </a:fillRef>
+          <a:effectRef idx="2">
+            <a:schemeClr val="accent1"/>
+          </a:effectRef>
+          <a:fontRef idx="minor">
+            <a:schemeClr val="lt1"/>
+          </a:fontRef>
+        </p:style>
+        <p:txBody>
+          <a:bodyPr rtlCol="0" anchor="ctr" wrap="square" lIns="182880" rIns="182880" tIns="164592"/>
+          <a:lstStyle/>
+          <a:p>
+            <a:pPr algn="ctr">
+              <a:spcAft>
+                <a:spcPts val="1000"/>
+              </a:spcAft>
+              <a:defRPr sz="1200" b="1">
+                <a:solidFill>
+                  <a:srgbClr val="1A365D"/>
+                </a:solidFill>
+                <a:latin typeface="Calibri"/>
+              </a:defRPr>
+            </a:pPr>
+            <a:r>
+              <a:t>1. Dual-Mode Deployment Topology</a:t>
+            </a:r>
+          </a:p>
+          <a:p>
+            <a:pPr>
+              <a:lnSpc>
+                <a:spcPct val="115000"/>
+              </a:lnSpc>
+              <a:spcAft>
+                <a:spcPts val="800"/>
+              </a:spcAft>
+              <a:defRPr sz="950">
+                <a:latin typeface="Calibri"/>
+              </a:defRPr>
+            </a:pPr>
+            <a:r>
+              <a:rPr b="1">
+                <a:solidFill>
+                  <a:srgbClr val="0F172A"/>
+                </a:solidFill>
+              </a:rPr>
+              <a:t>Cloud Production Architecture: </a:t>
+            </a:r>
+            <a:r>
+              <a:rPr>
+                <a:solidFill>
+                  <a:srgbClr val="334155"/>
+                </a:solidFill>
+              </a:rPr>
+              <a:t>React SPA hosted on Vercel Edge Network with global CDN and SSL termination. Containerized FastAPI server on Render/Railway. Supabase Cloud PostgreSQL with automated backups.</a:t>
+            </a:r>
+          </a:p>
+          <a:p>
+            <a:pPr>
+              <a:lnSpc>
+                <a:spcPct val="115000"/>
+              </a:lnSpc>
+              <a:spcAft>
+                <a:spcPts val="800"/>
+              </a:spcAft>
+              <a:defRPr sz="950">
+                <a:latin typeface="Calibri"/>
+              </a:defRPr>
+            </a:pPr>
+            <a:r>
+              <a:rPr b="1">
+                <a:solidFill>
+                  <a:srgbClr val="0F172A"/>
+                </a:solidFill>
+              </a:rPr>
+              <a:t>Local Campus Edge Mode: </a:t>
+            </a:r>
+            <a:r>
+              <a:rPr>
+                <a:solidFill>
+                  <a:srgbClr val="334155"/>
+                </a:solidFill>
+              </a:rPr>
+              <a:t>Single-command boot (npm run dev) executing concurrent FastAPI (port 5000) and Vite (port 5173). Zero external cloud dependencies.</a:t>
+            </a:r>
+          </a:p>
+          <a:p>
+            <a:pPr>
+              <a:lnSpc>
+                <a:spcPct val="115000"/>
+              </a:lnSpc>
+              <a:spcAft>
+                <a:spcPts val="800"/>
+              </a:spcAft>
+              <a:defRPr sz="950">
+                <a:latin typeface="Calibri"/>
+              </a:defRPr>
+            </a:pPr>
+            <a:r>
+              <a:rPr b="1">
+                <a:solidFill>
+                  <a:srgbClr val="0F172A"/>
+                </a:solidFill>
+              </a:rPr>
+              <a:t>Air-Gapped Operation: </a:t>
+            </a:r>
+            <a:r>
+              <a:rPr>
+                <a:solidFill>
+                  <a:srgbClr val="334155"/>
+                </a:solidFill>
+              </a:rPr>
+              <a:t>Ideal for high-density campus symposiums or network-isolated computer science labs during 36-hour hackathons.</a:t>
+            </a:r>
+          </a:p>
+          <a:p>
+            <a:pPr>
+              <a:lnSpc>
+                <a:spcPct val="115000"/>
+              </a:lnSpc>
+              <a:spcAft>
+                <a:spcPts val="800"/>
+              </a:spcAft>
+              <a:defRPr sz="950">
+                <a:latin typeface="Calibri"/>
+              </a:defRPr>
+            </a:pPr>
+            <a:r>
+              <a:rPr b="1">
+                <a:solidFill>
+                  <a:srgbClr val="0F172A"/>
+                </a:solidFill>
+              </a:rPr>
+              <a:t>Seamless Failover: </a:t>
+            </a:r>
+            <a:r>
+              <a:rPr>
+                <a:solidFill>
+                  <a:srgbClr val="334155"/>
+                </a:solidFill>
+              </a:rPr>
+              <a:t>Client api.js automatically detects cloud connectivity and routes queries without interface reload.</a:t>
+            </a:r>
+          </a:p>
+        </p:txBody>
+      </p:sp>
+      <p:sp>
+        <p:nvSpPr>
+          <p:cNvPr id="8" name="Rectangle 7"/>
+          <p:cNvSpPr/>
+          <p:nvPr/>
+        </p:nvSpPr>
+        <p:spPr>
+          <a:xfrm>
+            <a:off x="731520" y="1874519"/>
+            <a:ext cx="3410712" cy="91440"/>
+          </a:xfrm>
+          <a:prstGeom prst="rect">
+            <a:avLst/>
+          </a:prstGeom>
+          <a:solidFill>
+            <a:srgbClr val="2563EB"/>
+          </a:solidFill>
+          <a:ln>
+            <a:noFill/>
+          </a:ln>
+        </p:spPr>
+        <p:style>
+          <a:lnRef idx="1">
+            <a:schemeClr val="accent1"/>
+          </a:lnRef>
+          <a:fillRef idx="3">
+            <a:schemeClr val="accent1"/>
+          </a:fillRef>
+          <a:effectRef idx="2">
+            <a:schemeClr val="accent1"/>
+          </a:effectRef>
+          <a:fontRef idx="minor">
+            <a:schemeClr val="lt1"/>
+          </a:fontRef>
+        </p:style>
+        <p:txBody>
+          <a:bodyPr rtlCol="0" anchor="ctr"/>
+          <a:lstStyle/>
+          <a:p>
+            <a:pPr algn="ctr"/>
+          </a:p>
+        </p:txBody>
+      </p:sp>
+      <p:sp>
+        <p:nvSpPr>
+          <p:cNvPr id="9" name="Rounded Rectangle 8"/>
+          <p:cNvSpPr/>
+          <p:nvPr/>
+        </p:nvSpPr>
+        <p:spPr>
+          <a:xfrm>
+            <a:off x="4389120" y="1874519"/>
+            <a:ext cx="3410712" cy="4297680"/>
+          </a:xfrm>
+          <a:prstGeom prst="roundRect">
+            <a:avLst/>
+          </a:prstGeom>
+          <a:solidFill>
+            <a:srgbClr val="F8FAFC"/>
+          </a:solidFill>
+          <a:ln w="12700">
+            <a:solidFill>
+              <a:srgbClr val="E2E8F0"/>
+            </a:solidFill>
+          </a:ln>
+        </p:spPr>
+        <p:style>
+          <a:lnRef idx="1">
+            <a:schemeClr val="accent1"/>
+          </a:lnRef>
+          <a:fillRef idx="3">
+            <a:schemeClr val="accent1"/>
+          </a:fillRef>
+          <a:effectRef idx="2">
+            <a:schemeClr val="accent1"/>
+          </a:effectRef>
+          <a:fontRef idx="minor">
+            <a:schemeClr val="lt1"/>
+          </a:fontRef>
+        </p:style>
+        <p:txBody>
+          <a:bodyPr rtlCol="0" anchor="ctr" wrap="square" lIns="182880" rIns="182880" tIns="164592"/>
+          <a:lstStyle/>
+          <a:p>
+            <a:pPr algn="ctr">
+              <a:spcAft>
+                <a:spcPts val="1000"/>
+              </a:spcAft>
+              <a:defRPr sz="1200" b="1">
+                <a:solidFill>
+                  <a:srgbClr val="1A365D"/>
+                </a:solidFill>
+                <a:latin typeface="Calibri"/>
+              </a:defRPr>
+            </a:pPr>
+            <a:r>
+              <a:t>2. CI/CD Automation Pipeline</a:t>
+            </a:r>
+          </a:p>
+          <a:p>
+            <a:pPr>
+              <a:lnSpc>
+                <a:spcPct val="115000"/>
+              </a:lnSpc>
+              <a:spcAft>
+                <a:spcPts val="800"/>
+              </a:spcAft>
+              <a:defRPr sz="950">
+                <a:latin typeface="Calibri"/>
+              </a:defRPr>
+            </a:pPr>
+            <a:r>
+              <a:rPr b="1">
+                <a:solidFill>
+                  <a:srgbClr val="0F172A"/>
+                </a:solidFill>
+              </a:rPr>
+              <a:t>Stage 1: Lint &amp; Code Quality: </a:t>
+            </a:r>
+            <a:r>
+              <a:rPr>
+                <a:solidFill>
+                  <a:srgbClr val="334155"/>
+                </a:solidFill>
+              </a:rPr>
+              <a:t>Triggered on push/PR to main. Flake8 and Black for Python backend; ESLint for React JSX components.</a:t>
+            </a:r>
+          </a:p>
+          <a:p>
+            <a:pPr>
+              <a:lnSpc>
+                <a:spcPct val="115000"/>
+              </a:lnSpc>
+              <a:spcAft>
+                <a:spcPts val="800"/>
+              </a:spcAft>
+              <a:defRPr sz="950">
+                <a:latin typeface="Calibri"/>
+              </a:defRPr>
+            </a:pPr>
+            <a:r>
+              <a:rPr b="1">
+                <a:solidFill>
+                  <a:srgbClr val="0F172A"/>
+                </a:solidFill>
+              </a:rPr>
+              <a:t>Stage 2: Automated Pytest Suite: </a:t>
+            </a:r>
+            <a:r>
+              <a:rPr>
+                <a:solidFill>
+                  <a:srgbClr val="334155"/>
+                </a:solidFill>
+              </a:rPr>
+              <a:t>Executes all 28 automated test suites in isolated runner. Enforces 100% pass threshold prior to merge.</a:t>
+            </a:r>
+          </a:p>
+          <a:p>
+            <a:pPr>
+              <a:lnSpc>
+                <a:spcPct val="115000"/>
+              </a:lnSpc>
+              <a:spcAft>
+                <a:spcPts val="800"/>
+              </a:spcAft>
+              <a:defRPr sz="950">
+                <a:latin typeface="Calibri"/>
+              </a:defRPr>
+            </a:pPr>
+            <a:r>
+              <a:rPr b="1">
+                <a:solidFill>
+                  <a:srgbClr val="0F172A"/>
+                </a:solidFill>
+              </a:rPr>
+              <a:t>Stage 3: Production Client Build: </a:t>
+            </a:r>
+            <a:r>
+              <a:rPr>
+                <a:solidFill>
+                  <a:srgbClr val="334155"/>
+                </a:solidFill>
+              </a:rPr>
+              <a:t>Compiles React production bundle via npm run build. Verifies asset minification and zero missing modules in dist/.</a:t>
+            </a:r>
+          </a:p>
+          <a:p>
+            <a:pPr>
+              <a:lnSpc>
+                <a:spcPct val="115000"/>
+              </a:lnSpc>
+              <a:spcAft>
+                <a:spcPts val="800"/>
+              </a:spcAft>
+              <a:defRPr sz="950">
+                <a:latin typeface="Calibri"/>
+              </a:defRPr>
+            </a:pPr>
+            <a:r>
+              <a:rPr b="1">
+                <a:solidFill>
+                  <a:srgbClr val="0F172A"/>
+                </a:solidFill>
+              </a:rPr>
+              <a:t>Stage 4: Container Packaging &amp; Rollout: </a:t>
+            </a:r>
+            <a:r>
+              <a:rPr>
+                <a:solidFill>
+                  <a:srgbClr val="334155"/>
+                </a:solidFill>
+              </a:rPr>
+              <a:t>Multi-stage Docker build deployed with zero-downtime rolling update; automated rollback if /api/health probe fails.</a:t>
+            </a:r>
+          </a:p>
+        </p:txBody>
+      </p:sp>
+      <p:sp>
+        <p:nvSpPr>
+          <p:cNvPr id="10" name="Rectangle 9"/>
+          <p:cNvSpPr/>
+          <p:nvPr/>
+        </p:nvSpPr>
+        <p:spPr>
+          <a:xfrm>
+            <a:off x="4389120" y="1874519"/>
+            <a:ext cx="3410712" cy="91440"/>
+          </a:xfrm>
+          <a:prstGeom prst="rect">
+            <a:avLst/>
+          </a:prstGeom>
+          <a:solidFill>
+            <a:srgbClr val="1A365D"/>
+          </a:solidFill>
+          <a:ln>
+            <a:noFill/>
+          </a:ln>
+        </p:spPr>
+        <p:style>
+          <a:lnRef idx="1">
+            <a:schemeClr val="accent1"/>
+          </a:lnRef>
+          <a:fillRef idx="3">
+            <a:schemeClr val="accent1"/>
+          </a:fillRef>
+          <a:effectRef idx="2">
+            <a:schemeClr val="accent1"/>
+          </a:effectRef>
+          <a:fontRef idx="minor">
+            <a:schemeClr val="lt1"/>
+          </a:fontRef>
+        </p:style>
+        <p:txBody>
+          <a:bodyPr rtlCol="0" anchor="ctr"/>
+          <a:lstStyle/>
+          <a:p>
+            <a:pPr algn="ctr"/>
+          </a:p>
+        </p:txBody>
+      </p:sp>
+      <p:sp>
+        <p:nvSpPr>
+          <p:cNvPr id="11" name="Rounded Rectangle 10"/>
+          <p:cNvSpPr/>
+          <p:nvPr/>
+        </p:nvSpPr>
+        <p:spPr>
+          <a:xfrm>
+            <a:off x="8046720" y="1874519"/>
+            <a:ext cx="3410712" cy="4297680"/>
+          </a:xfrm>
+          <a:prstGeom prst="roundRect">
+            <a:avLst/>
+          </a:prstGeom>
+          <a:solidFill>
+            <a:srgbClr val="F8FAFC"/>
+          </a:solidFill>
+          <a:ln w="12700">
+            <a:solidFill>
+              <a:srgbClr val="E2E8F0"/>
+            </a:solidFill>
+          </a:ln>
+        </p:spPr>
+        <p:style>
+          <a:lnRef idx="1">
+            <a:schemeClr val="accent1"/>
+          </a:lnRef>
+          <a:fillRef idx="3">
+            <a:schemeClr val="accent1"/>
+          </a:fillRef>
+          <a:effectRef idx="2">
+            <a:schemeClr val="accent1"/>
+          </a:effectRef>
+          <a:fontRef idx="minor">
+            <a:schemeClr val="lt1"/>
+          </a:fontRef>
+        </p:style>
+        <p:txBody>
+          <a:bodyPr rtlCol="0" anchor="ctr" wrap="square" lIns="182880" rIns="182880" tIns="164592"/>
+          <a:lstStyle/>
+          <a:p>
+            <a:pPr algn="ctr">
+              <a:spcAft>
+                <a:spcPts val="1000"/>
+              </a:spcAft>
+              <a:defRPr sz="1200" b="1">
+                <a:solidFill>
+                  <a:srgbClr val="1A365D"/>
+                </a:solidFill>
+                <a:latin typeface="Calibri"/>
+              </a:defRPr>
+            </a:pPr>
+            <a:r>
+              <a:t>3. Operational Security &amp; Database Hardening</a:t>
+            </a:r>
+          </a:p>
+          <a:p>
+            <a:pPr>
+              <a:lnSpc>
+                <a:spcPct val="115000"/>
+              </a:lnSpc>
+              <a:spcAft>
+                <a:spcPts val="800"/>
+              </a:spcAft>
+              <a:defRPr sz="950">
+                <a:latin typeface="Calibri"/>
+              </a:defRPr>
+            </a:pPr>
+            <a:r>
+              <a:rPr b="1">
+                <a:solidFill>
+                  <a:srgbClr val="0F172A"/>
+                </a:solidFill>
+              </a:rPr>
+              <a:t>Row-Level Security (RLS): </a:t>
+            </a:r>
+            <a:r>
+              <a:rPr>
+                <a:solidFill>
+                  <a:srgbClr val="334155"/>
+                </a:solidFill>
+              </a:rPr>
+              <a:t>Granular PostgreSQL RLS policies restrict table mutations. Public anon keys permitted read-only access for published events.</a:t>
+            </a:r>
+          </a:p>
+          <a:p>
+            <a:pPr>
+              <a:lnSpc>
+                <a:spcPct val="115000"/>
+              </a:lnSpc>
+              <a:spcAft>
+                <a:spcPts val="800"/>
+              </a:spcAft>
+              <a:defRPr sz="950">
+                <a:latin typeface="Calibri"/>
+              </a:defRPr>
+            </a:pPr>
+            <a:r>
+              <a:rPr b="1">
+                <a:solidFill>
+                  <a:srgbClr val="0F172A"/>
+                </a:solidFill>
+              </a:rPr>
+              <a:t>SQLite WAL Concurrency Tuning: </a:t>
+            </a:r>
+            <a:r>
+              <a:rPr>
+                <a:solidFill>
+                  <a:srgbClr val="334155"/>
+                </a:solidFill>
+              </a:rPr>
+              <a:t>PRAGMA journal_mode = WAL enables concurrent readers without writer contention. PRAGMA busy_timeout = 5000 eliminates busy crashes.</a:t>
+            </a:r>
+          </a:p>
+          <a:p>
+            <a:pPr>
+              <a:lnSpc>
+                <a:spcPct val="115000"/>
+              </a:lnSpc>
+              <a:spcAft>
+                <a:spcPts val="800"/>
+              </a:spcAft>
+              <a:defRPr sz="950">
+                <a:latin typeface="Calibri"/>
+              </a:defRPr>
+            </a:pPr>
+            <a:r>
+              <a:rPr b="1">
+                <a:solidFill>
+                  <a:srgbClr val="0F172A"/>
+                </a:solidFill>
+              </a:rPr>
+              <a:t>Environment Segregation: </a:t>
+            </a:r>
+            <a:r>
+              <a:rPr>
+                <a:solidFill>
+                  <a:srgbClr val="334155"/>
+                </a:solidFill>
+              </a:rPr>
+              <a:t>Strict .env isolation separates public client keys (VITE_SUPABASE_ANON_KEY) from backend secrets. CORS origin whitelisting.</a:t>
+            </a:r>
+          </a:p>
+          <a:p>
+            <a:pPr>
+              <a:lnSpc>
+                <a:spcPct val="115000"/>
+              </a:lnSpc>
+              <a:spcAft>
+                <a:spcPts val="800"/>
+              </a:spcAft>
+              <a:defRPr sz="950">
+                <a:latin typeface="Calibri"/>
+              </a:defRPr>
+            </a:pPr>
+            <a:r>
+              <a:rPr b="1">
+                <a:solidFill>
+                  <a:srgbClr val="0F172A"/>
+                </a:solidFill>
+              </a:rPr>
+              <a:t>Health Probes &amp; Telemetry: </a:t>
+            </a:r>
+            <a:r>
+              <a:rPr>
+                <a:solidFill>
+                  <a:srgbClr val="334155"/>
+                </a:solidFill>
+              </a:rPr>
+              <a:t>GET /api/health continuously monitors database responsiveness and memory consumption for proactive operations.</a:t>
+            </a:r>
+          </a:p>
+        </p:txBody>
+      </p:sp>
+      <p:sp>
+        <p:nvSpPr>
+          <p:cNvPr id="12" name="Rectangle 11"/>
+          <p:cNvSpPr/>
+          <p:nvPr/>
+        </p:nvSpPr>
+        <p:spPr>
+          <a:xfrm>
+            <a:off x="8046720" y="1874519"/>
+            <a:ext cx="3410712" cy="91440"/>
+          </a:xfrm>
+          <a:prstGeom prst="rect">
+            <a:avLst/>
+          </a:prstGeom>
+          <a:solidFill>
+            <a:srgbClr val="0F172A"/>
+          </a:solidFill>
+          <a:ln>
+            <a:noFill/>
+          </a:ln>
+        </p:spPr>
+        <p:style>
+          <a:lnRef idx="1">
+            <a:schemeClr val="accent1"/>
+          </a:lnRef>
+          <a:fillRef idx="3">
+            <a:schemeClr val="accent1"/>
+          </a:fillRef>
+          <a:effectRef idx="2">
+            <a:schemeClr val="accent1"/>
+          </a:effectRef>
+          <a:fontRef idx="minor">
+            <a:schemeClr val="lt1"/>
+          </a:fontRef>
+        </p:style>
+        <p:txBody>
+          <a:bodyPr rtlCol="0" anchor="ctr"/>
+          <a:lstStyle/>
+          <a:p>
+            <a:pPr algn="ctr"/>
+          </a:p>
+        </p:txBody>
+      </p:sp>
+    </p:spTree>
+  </p:cSld>
+  <p:clrMapOvr>
+    <a:masterClrMapping/>
+  </p:clrMapOvr>
+</p:sld>
+</file>
+
+<file path=ppt/slides/slide13.xml><?xml version="1.0" encoding="utf-8"?>
+<p:sld xmlns:a="http://schemas.openxmlformats.org/drawingml/2006/main" xmlns:p="http://schemas.openxmlformats.org/presentationml/2006/main" xmlns:r="http://schemas.openxmlformats.org/officeDocument/2006/relationships">
+  <p:cSld>
+    <p:spTree>
+      <p:nvGrpSpPr>
+        <p:cNvPr id="1" name=""/>
+        <p:cNvGrpSpPr/>
+        <p:nvPr/>
+      </p:nvGrpSpPr>
+      <p:grpSpPr/>
+      <p:sp>
+        <p:nvSpPr>
+          <p:cNvPr id="2" name="Rounded Rectangle 1"/>
+          <p:cNvSpPr/>
+          <p:nvPr/>
+        </p:nvSpPr>
+        <p:spPr>
+          <a:xfrm>
+            <a:off x="731520" y="411480"/>
+            <a:ext cx="4114800" cy="292608"/>
+          </a:xfrm>
+          <a:prstGeom prst="roundRect">
+            <a:avLst/>
+          </a:prstGeom>
+          <a:solidFill>
+            <a:srgbClr val="EEF2FF"/>
+          </a:solidFill>
+          <a:ln w="12700">
+            <a:solidFill>
+              <a:srgbClr val="C7D2FE"/>
+            </a:solidFill>
+          </a:ln>
+        </p:spPr>
+        <p:style>
+          <a:lnRef idx="1">
+            <a:schemeClr val="accent1"/>
+          </a:lnRef>
+          <a:fillRef idx="3">
+            <a:schemeClr val="accent1"/>
+          </a:fillRef>
+          <a:effectRef idx="2">
+            <a:schemeClr val="accent1"/>
+          </a:effectRef>
+          <a:fontRef idx="minor">
+            <a:schemeClr val="lt1"/>
+          </a:fontRef>
+        </p:style>
+        <p:txBody>
+          <a:bodyPr rtlCol="0" anchor="ctr" wrap="square" lIns="109728" tIns="36576"/>
+          <a:lstStyle/>
+          <a:p>
+            <a:pPr algn="ctr">
+              <a:defRPr sz="950" b="1">
+                <a:solidFill>
+                  <a:srgbClr val="312E81"/>
+                </a:solidFill>
+                <a:latin typeface="Calibri"/>
+              </a:defRPr>
+            </a:pPr>
+            <a:r>
+              <a:t>SOFTWARE ENGINEERING LIFECYCLE | PHASE 5</a:t>
+            </a:r>
+          </a:p>
+        </p:txBody>
+      </p:sp>
+      <p:sp>
+        <p:nvSpPr>
+          <p:cNvPr id="3" name="TextBox 2"/>
+          <p:cNvSpPr txBox="1"/>
+          <p:nvPr/>
+        </p:nvSpPr>
+        <p:spPr>
+          <a:xfrm>
+            <a:off x="731520" y="777240"/>
+            <a:ext cx="10698480" cy="868680"/>
+          </a:xfrm>
+          <a:prstGeom prst="rect">
+            <a:avLst/>
+          </a:prstGeom>
+          <a:noFill/>
+        </p:spPr>
+        <p:txBody>
+          <a:bodyPr wrap="square" lIns="0" tIns="0" rIns="0" bIns="0">
+            <a:spAutoFit/>
+          </a:bodyPr>
+          <a:lstStyle/>
+          <a:p>
+            <a:pPr>
+              <a:defRPr sz="2200" b="1">
+                <a:solidFill>
+                  <a:srgbClr val="1A365D"/>
+                </a:solidFill>
+                <a:latin typeface="Calibri"/>
+              </a:defRPr>
+            </a:pPr>
+            <a:r>
+              <a:t>Module 5: Performance Analysis &amp; Concurrency Benchmarks</a:t>
+            </a:r>
+          </a:p>
+          <a:p>
+            <a:pPr>
+              <a:spcBef>
+                <a:spcPts val="300"/>
+              </a:spcBef>
+              <a:defRPr sz="1200">
+                <a:solidFill>
+                  <a:srgbClr val="64748B"/>
+                </a:solidFill>
+                <a:latin typeface="Calibri"/>
+              </a:defRPr>
+            </a:pPr>
+            <a:r>
+              <a:t>Computational complexity comparisons, empirical latency profiling, and stress-tested race condition mitigation</a:t>
+            </a:r>
+          </a:p>
+        </p:txBody>
+      </p:sp>
+      <p:sp>
+        <p:nvSpPr>
+          <p:cNvPr id="4" name="Rectangle 3"/>
+          <p:cNvSpPr/>
+          <p:nvPr/>
+        </p:nvSpPr>
+        <p:spPr>
+          <a:xfrm>
+            <a:off x="731520" y="1691640"/>
+            <a:ext cx="10725912" cy="18288"/>
+          </a:xfrm>
+          <a:prstGeom prst="rect">
+            <a:avLst/>
+          </a:prstGeom>
+          <a:solidFill>
+            <a:srgbClr val="E2E8F0"/>
+          </a:solidFill>
+          <a:ln>
+            <a:solidFill>
+              <a:srgbClr val="E2E8F0"/>
+            </a:solidFill>
+          </a:ln>
+        </p:spPr>
+        <p:style>
+          <a:lnRef idx="1">
+            <a:schemeClr val="accent1"/>
+          </a:lnRef>
+          <a:fillRef idx="3">
+            <a:schemeClr val="accent1"/>
+          </a:fillRef>
+          <a:effectRef idx="2">
+            <a:schemeClr val="accent1"/>
+          </a:effectRef>
+          <a:fontRef idx="minor">
+            <a:schemeClr val="lt1"/>
+          </a:fontRef>
+        </p:style>
+        <p:txBody>
+          <a:bodyPr rtlCol="0" anchor="ctr"/>
+          <a:lstStyle/>
+          <a:p>
+            <a:pPr algn="ctr"/>
+          </a:p>
+        </p:txBody>
+      </p:sp>
+      <p:sp>
+        <p:nvSpPr>
+          <p:cNvPr id="5" name="TextBox 4"/>
+          <p:cNvSpPr txBox="1"/>
+          <p:nvPr/>
+        </p:nvSpPr>
+        <p:spPr>
+          <a:xfrm>
+            <a:off x="731520" y="6400800"/>
+            <a:ext cx="7315200" cy="274320"/>
+          </a:xfrm>
+          <a:prstGeom prst="rect">
+            <a:avLst/>
+          </a:prstGeom>
+          <a:noFill/>
+        </p:spPr>
+        <p:txBody>
+          <a:bodyPr wrap="square" lIns="0" tIns="0">
+            <a:spAutoFit/>
+          </a:bodyPr>
+          <a:lstStyle/>
+          <a:p>
+            <a:pPr>
+              <a:defRPr sz="900">
+                <a:solidFill>
+                  <a:srgbClr val="64748B"/>
+                </a:solidFill>
+                <a:latin typeface="Calibri"/>
+              </a:defRPr>
+            </a:pPr>
+            <a:r>
+              <a:t>CSA1021 - Software Engineering | Capstone Project 2026 | Saveetha School of Engineering (SIMATS)</a:t>
+            </a:r>
+          </a:p>
+        </p:txBody>
+      </p:sp>
+      <p:sp>
+        <p:nvSpPr>
+          <p:cNvPr id="6" name="TextBox 5"/>
+          <p:cNvSpPr txBox="1"/>
+          <p:nvPr/>
+        </p:nvSpPr>
+        <p:spPr>
+          <a:xfrm>
+            <a:off x="9601200" y="6400800"/>
+            <a:ext cx="1828800" cy="274320"/>
+          </a:xfrm>
+          <a:prstGeom prst="rect">
+            <a:avLst/>
+          </a:prstGeom>
+          <a:noFill/>
+        </p:spPr>
+        <p:txBody>
+          <a:bodyPr wrap="square" rIns="0" tIns="0">
+            <a:spAutoFit/>
+          </a:bodyPr>
+          <a:lstStyle/>
+          <a:p>
+            <a:pPr algn="r">
+              <a:defRPr sz="900">
+                <a:solidFill>
+                  <a:srgbClr val="64748B"/>
+                </a:solidFill>
+                <a:latin typeface="Calibri"/>
+              </a:defRPr>
+            </a:pPr>
+            <a:r>
+              <a:t>Slide 13 of 13</a:t>
+            </a:r>
+          </a:p>
+        </p:txBody>
+      </p:sp>
+      <p:graphicFrame>
+        <p:nvGraphicFramePr>
+          <p:cNvPr id="7" name="Table 6"/>
+          <p:cNvGraphicFramePr>
+            <a:graphicFrameLocks noGrp="1"/>
+          </p:cNvGraphicFramePr>
+          <p:nvPr/>
+        </p:nvGraphicFramePr>
+        <p:xfrm>
+          <a:off x="731520" y="1874519"/>
+          <a:ext cx="10725912" cy="1965960"/>
+        </p:xfrm>
+        <a:graphic>
+          <a:graphicData uri="http://schemas.openxmlformats.org/drawingml/2006/table">
+            <a:tbl>
+              <a:tblPr firstRow="1" bandRow="1">
+                <a:tableStyleId>{5C22544A-7EE6-4342-B048-85BDC9FD1C3A}</a:tableStyleId>
+              </a:tblPr>
+              <a:tblGrid>
+                <a:gridCol w="2560320"/>
+                <a:gridCol w="2103120"/>
+                <a:gridCol w="2194560"/>
+                <a:gridCol w="1920240"/>
+                <a:gridCol w="1947672"/>
+              </a:tblGrid>
+              <a:tr h="393192">
+                <a:tc>
+                  <a:txBody>
+                    <a:bodyPr wrap="square" tIns="54864"/>
+                    <a:lstStyle/>
+                    <a:p>
+                      <a:pPr>
+                        <a:defRPr sz="1000" b="1">
+                          <a:solidFill>
+                            <a:srgbClr val="FFFFFF"/>
+                          </a:solidFill>
+                          <a:latin typeface="Calibri"/>
+                        </a:defRPr>
+                      </a:pPr>
+                      <a:r>
+                        <a:t>Scheduling Methodology</a:t>
+                      </a:r>
+                    </a:p>
+                  </a:txBody>
+                  <a:tcPr>
+                    <a:solidFill>
+                      <a:srgbClr val="1A365D"/>
+                    </a:solidFill>
+                  </a:tcPr>
+                </a:tc>
+                <a:tc>
+                  <a:txBody>
+                    <a:bodyPr wrap="square" tIns="54864"/>
+                    <a:lstStyle/>
+                    <a:p>
+                      <a:pPr>
+                        <a:defRPr sz="1000" b="1">
+                          <a:solidFill>
+                            <a:srgbClr val="FFFFFF"/>
+                          </a:solidFill>
+                          <a:latin typeface="Calibri"/>
+                        </a:defRPr>
+                      </a:pPr>
+                      <a:r>
+                        <a:t>Single Collision Check</a:t>
+                      </a:r>
+                    </a:p>
+                  </a:txBody>
+                  <a:tcPr>
+                    <a:solidFill>
+                      <a:srgbClr val="1A365D"/>
+                    </a:solidFill>
+                  </a:tcPr>
+                </a:tc>
+                <a:tc>
+                  <a:txBody>
+                    <a:bodyPr wrap="square" tIns="54864"/>
+                    <a:lstStyle/>
+                    <a:p>
+                      <a:pPr>
+                        <a:defRPr sz="1000" b="1">
+                          <a:solidFill>
+                            <a:srgbClr val="FFFFFF"/>
+                          </a:solidFill>
+                          <a:latin typeface="Calibri"/>
+                        </a:defRPr>
+                      </a:pPr>
+                      <a:r>
+                        <a:t>Batch Optimization</a:t>
+                      </a:r>
+                    </a:p>
+                  </a:txBody>
+                  <a:tcPr>
+                    <a:solidFill>
+                      <a:srgbClr val="1A365D"/>
+                    </a:solidFill>
+                  </a:tcPr>
+                </a:tc>
+                <a:tc>
+                  <a:txBody>
+                    <a:bodyPr wrap="square" tIns="54864"/>
+                    <a:lstStyle/>
+                    <a:p>
+                      <a:pPr>
+                        <a:defRPr sz="1000" b="1">
+                          <a:solidFill>
+                            <a:srgbClr val="FFFFFF"/>
+                          </a:solidFill>
+                          <a:latin typeface="Calibri"/>
+                        </a:defRPr>
+                      </a:pPr>
+                      <a:r>
+                        <a:t>Time for 10,000 Ops</a:t>
+                      </a:r>
+                    </a:p>
+                  </a:txBody>
+                  <a:tcPr>
+                    <a:solidFill>
+                      <a:srgbClr val="1A365D"/>
+                    </a:solidFill>
+                  </a:tcPr>
+                </a:tc>
+                <a:tc>
+                  <a:txBody>
+                    <a:bodyPr wrap="square" tIns="54864"/>
+                    <a:lstStyle/>
+                    <a:p>
+                      <a:pPr>
+                        <a:defRPr sz="1000" b="1">
+                          <a:solidFill>
+                            <a:srgbClr val="FFFFFF"/>
+                          </a:solidFill>
+                          <a:latin typeface="Calibri"/>
+                        </a:defRPr>
+                      </a:pPr>
+                      <a:r>
+                        <a:t>TOCTOU Race Safety</a:t>
+                      </a:r>
+                    </a:p>
+                  </a:txBody>
+                  <a:tcPr>
+                    <a:solidFill>
+                      <a:srgbClr val="1A365D"/>
+                    </a:solidFill>
+                  </a:tcPr>
+                </a:tc>
+              </a:tr>
+              <a:tr h="393192">
+                <a:tc>
+                  <a:txBody>
+                    <a:bodyPr wrap="square"/>
+                    <a:lstStyle/>
+                    <a:p>
+                      <a:pPr>
+                        <a:defRPr sz="900" b="1">
+                          <a:solidFill>
+                            <a:srgbClr val="0F172A"/>
+                          </a:solidFill>
+                          <a:latin typeface="Calibri"/>
+                        </a:defRPr>
+                      </a:pPr>
+                      <a:r>
+                        <a:t>Manual Spreadsheets / Paper Forms</a:t>
+                      </a:r>
+                    </a:p>
+                  </a:txBody>
+                  <a:tcPr>
+                    <a:solidFill>
+                      <a:srgbClr val="F8FAFC"/>
+                    </a:solidFill>
+                  </a:tcPr>
+                </a:tc>
+                <a:tc>
+                  <a:txBody>
+                    <a:bodyPr wrap="square"/>
+                    <a:lstStyle/>
+                    <a:p>
+                      <a:pPr>
+                        <a:defRPr sz="900">
+                          <a:solidFill>
+                            <a:srgbClr val="334155"/>
+                          </a:solidFill>
+                          <a:latin typeface="Calibri"/>
+                        </a:defRPr>
+                      </a:pPr>
+                      <a:r>
+                        <a:t>O(N) (Manual lookup)</a:t>
+                      </a:r>
+                    </a:p>
+                  </a:txBody>
+                  <a:tcPr>
+                    <a:solidFill>
+                      <a:srgbClr val="F8FAFC"/>
+                    </a:solidFill>
+                  </a:tcPr>
+                </a:tc>
+                <a:tc>
+                  <a:txBody>
+                    <a:bodyPr wrap="square"/>
+                    <a:lstStyle/>
+                    <a:p>
+                      <a:pPr>
+                        <a:defRPr sz="900">
+                          <a:solidFill>
+                            <a:srgbClr val="334155"/>
+                          </a:solidFill>
+                          <a:latin typeface="Calibri"/>
+                        </a:defRPr>
+                      </a:pPr>
+                      <a:r>
+                        <a:t>Unbounded (Manual)</a:t>
+                      </a:r>
+                    </a:p>
+                  </a:txBody>
+                  <a:tcPr>
+                    <a:solidFill>
+                      <a:srgbClr val="F8FAFC"/>
+                    </a:solidFill>
+                  </a:tcPr>
+                </a:tc>
+                <a:tc>
+                  <a:txBody>
+                    <a:bodyPr wrap="square"/>
+                    <a:lstStyle/>
+                    <a:p>
+                      <a:pPr>
+                        <a:defRPr sz="900">
+                          <a:solidFill>
+                            <a:srgbClr val="334155"/>
+                          </a:solidFill>
+                          <a:latin typeface="Calibri"/>
+                        </a:defRPr>
+                      </a:pPr>
+                      <a:r>
+                        <a:t>Minutes to Days</a:t>
+                      </a:r>
+                    </a:p>
+                  </a:txBody>
+                  <a:tcPr>
+                    <a:solidFill>
+                      <a:srgbClr val="F8FAFC"/>
+                    </a:solidFill>
+                  </a:tcPr>
+                </a:tc>
+                <a:tc>
+                  <a:txBody>
+                    <a:bodyPr wrap="square"/>
+                    <a:lstStyle/>
+                    <a:p>
+                      <a:pPr>
+                        <a:defRPr sz="900">
+                          <a:solidFill>
+                            <a:srgbClr val="334155"/>
+                          </a:solidFill>
+                          <a:latin typeface="Calibri"/>
+                        </a:defRPr>
+                      </a:pPr>
+                      <a:r>
+                        <a:t>Zero (High Collision)</a:t>
+                      </a:r>
+                    </a:p>
+                  </a:txBody>
+                  <a:tcPr>
+                    <a:solidFill>
+                      <a:srgbClr val="F8FAFC"/>
+                    </a:solidFill>
+                  </a:tcPr>
+                </a:tc>
+              </a:tr>
+              <a:tr h="393192">
+                <a:tc>
+                  <a:txBody>
+                    <a:bodyPr wrap="square"/>
+                    <a:lstStyle/>
+                    <a:p>
+                      <a:pPr>
+                        <a:defRPr sz="900" b="1">
+                          <a:solidFill>
+                            <a:srgbClr val="0F172A"/>
+                          </a:solidFill>
+                          <a:latin typeface="Calibri"/>
+                        </a:defRPr>
+                      </a:pPr>
+                      <a:r>
+                        <a:t>Naive SQL Linear Scan</a:t>
+                      </a:r>
+                    </a:p>
+                  </a:txBody>
+                  <a:tcPr>
+                    <a:solidFill>
+                      <a:srgbClr val="FFFFFF"/>
+                    </a:solidFill>
+                  </a:tcPr>
+                </a:tc>
+                <a:tc>
+                  <a:txBody>
+                    <a:bodyPr wrap="square"/>
+                    <a:lstStyle/>
+                    <a:p>
+                      <a:pPr>
+                        <a:defRPr sz="900">
+                          <a:solidFill>
+                            <a:srgbClr val="334155"/>
+                          </a:solidFill>
+                          <a:latin typeface="Calibri"/>
+                        </a:defRPr>
+                      </a:pPr>
+                      <a:r>
+                        <a:t>O(N) table scan</a:t>
+                      </a:r>
+                    </a:p>
+                  </a:txBody>
+                  <a:tcPr>
+                    <a:solidFill>
+                      <a:srgbClr val="FFFFFF"/>
+                    </a:solidFill>
+                  </a:tcPr>
+                </a:tc>
+                <a:tc>
+                  <a:txBody>
+                    <a:bodyPr wrap="square"/>
+                    <a:lstStyle/>
+                    <a:p>
+                      <a:pPr>
+                        <a:defRPr sz="900">
+                          <a:solidFill>
+                            <a:srgbClr val="334155"/>
+                          </a:solidFill>
+                          <a:latin typeface="Calibri"/>
+                        </a:defRPr>
+                      </a:pPr>
+                      <a:r>
+                        <a:t>O(N^2) pairwise compare</a:t>
+                      </a:r>
+                    </a:p>
+                  </a:txBody>
+                  <a:tcPr>
+                    <a:solidFill>
+                      <a:srgbClr val="FFFFFF"/>
+                    </a:solidFill>
+                  </a:tcPr>
+                </a:tc>
+                <a:tc>
+                  <a:txBody>
+                    <a:bodyPr wrap="square"/>
+                    <a:lstStyle/>
+                    <a:p>
+                      <a:pPr>
+                        <a:defRPr sz="900">
+                          <a:solidFill>
+                            <a:srgbClr val="334155"/>
+                          </a:solidFill>
+                          <a:latin typeface="Calibri"/>
+                        </a:defRPr>
+                      </a:pPr>
+                      <a:r>
+                        <a:t>42.3 ms</a:t>
+                      </a:r>
+                    </a:p>
+                  </a:txBody>
+                  <a:tcPr>
+                    <a:solidFill>
+                      <a:srgbClr val="FFFFFF"/>
+                    </a:solidFill>
+                  </a:tcPr>
+                </a:tc>
+                <a:tc>
+                  <a:txBody>
+                    <a:bodyPr wrap="square"/>
+                    <a:lstStyle/>
+                    <a:p>
+                      <a:pPr>
+                        <a:defRPr sz="900">
+                          <a:solidFill>
+                            <a:srgbClr val="334155"/>
+                          </a:solidFill>
+                          <a:latin typeface="Calibri"/>
+                        </a:defRPr>
+                      </a:pPr>
+                      <a:r>
+                        <a:t>Vulnerable (Interleaved)</a:t>
+                      </a:r>
+                    </a:p>
+                  </a:txBody>
+                  <a:tcPr>
+                    <a:solidFill>
+                      <a:srgbClr val="FFFFFF"/>
+                    </a:solidFill>
+                  </a:tcPr>
+                </a:tc>
+              </a:tr>
+              <a:tr h="393192">
+                <a:tc>
+                  <a:txBody>
+                    <a:bodyPr wrap="square"/>
+                    <a:lstStyle/>
+                    <a:p>
+                      <a:pPr>
+                        <a:defRPr sz="900" b="1">
+                          <a:solidFill>
+                            <a:srgbClr val="0F172A"/>
+                          </a:solidFill>
+                          <a:latin typeface="Calibri"/>
+                        </a:defRPr>
+                      </a:pPr>
+                      <a:r>
+                        <a:t>Genetic Algorithm (Literature 2025)</a:t>
+                      </a:r>
+                    </a:p>
+                  </a:txBody>
+                  <a:tcPr>
+                    <a:solidFill>
+                      <a:srgbClr val="F8FAFC"/>
+                    </a:solidFill>
+                  </a:tcPr>
+                </a:tc>
+                <a:tc>
+                  <a:txBody>
+                    <a:bodyPr wrap="square"/>
+                    <a:lstStyle/>
+                    <a:p>
+                      <a:pPr>
+                        <a:defRPr sz="900">
+                          <a:solidFill>
+                            <a:srgbClr val="334155"/>
+                          </a:solidFill>
+                          <a:latin typeface="Calibri"/>
+                        </a:defRPr>
+                      </a:pPr>
+                      <a:r>
+                        <a:t>O(G · P · C) stochastic</a:t>
+                      </a:r>
+                    </a:p>
+                  </a:txBody>
+                  <a:tcPr>
+                    <a:solidFill>
+                      <a:srgbClr val="F8FAFC"/>
+                    </a:solidFill>
+                  </a:tcPr>
+                </a:tc>
+                <a:tc>
+                  <a:txBody>
+                    <a:bodyPr wrap="square"/>
+                    <a:lstStyle/>
+                    <a:p>
+                      <a:pPr>
+                        <a:defRPr sz="900">
+                          <a:solidFill>
+                            <a:srgbClr val="334155"/>
+                          </a:solidFill>
+                          <a:latin typeface="Calibri"/>
+                        </a:defRPr>
+                      </a:pPr>
+                      <a:r>
+                        <a:t>O(G · P · C) heuristic</a:t>
+                      </a:r>
+                    </a:p>
+                  </a:txBody>
+                  <a:tcPr>
+                    <a:solidFill>
+                      <a:srgbClr val="F8FAFC"/>
+                    </a:solidFill>
+                  </a:tcPr>
+                </a:tc>
+                <a:tc>
+                  <a:txBody>
+                    <a:bodyPr wrap="square"/>
+                    <a:lstStyle/>
+                    <a:p>
+                      <a:pPr>
+                        <a:defRPr sz="900">
+                          <a:solidFill>
+                            <a:srgbClr val="334155"/>
+                          </a:solidFill>
+                          <a:latin typeface="Calibri"/>
+                        </a:defRPr>
+                      </a:pPr>
+                      <a:r>
+                        <a:t>~2,400 ms</a:t>
+                      </a:r>
+                    </a:p>
+                  </a:txBody>
+                  <a:tcPr>
+                    <a:solidFill>
+                      <a:srgbClr val="F8FAFC"/>
+                    </a:solidFill>
+                  </a:tcPr>
+                </a:tc>
+                <a:tc>
+                  <a:txBody>
+                    <a:bodyPr wrap="square"/>
+                    <a:lstStyle/>
+                    <a:p>
+                      <a:pPr>
+                        <a:defRPr sz="900">
+                          <a:solidFill>
+                            <a:srgbClr val="334155"/>
+                          </a:solidFill>
+                          <a:latin typeface="Calibri"/>
+                        </a:defRPr>
+                      </a:pPr>
+                      <a:r>
+                        <a:t>Vulnerable (High Latency)</a:t>
+                      </a:r>
+                    </a:p>
+                  </a:txBody>
+                  <a:tcPr>
+                    <a:solidFill>
+                      <a:srgbClr val="F8FAFC"/>
+                    </a:solidFill>
+                  </a:tcPr>
+                </a:tc>
+              </a:tr>
+              <a:tr h="393192">
+                <a:tc>
+                  <a:txBody>
+                    <a:bodyPr wrap="square"/>
+                    <a:lstStyle/>
+                    <a:p>
+                      <a:pPr>
+                        <a:defRPr sz="900" b="1">
+                          <a:solidFill>
+                            <a:srgbClr val="312E81"/>
+                          </a:solidFill>
+                          <a:latin typeface="Calibri"/>
+                        </a:defRPr>
+                      </a:pPr>
+                      <a:r>
+                        <a:t>EventFlow Interval Engine (Proposed)</a:t>
+                      </a:r>
+                    </a:p>
+                  </a:txBody>
+                  <a:tcPr>
+                    <a:solidFill>
+                      <a:srgbClr val="EEF2FF"/>
+                    </a:solidFill>
+                  </a:tcPr>
+                </a:tc>
+                <a:tc>
+                  <a:txBody>
+                    <a:bodyPr wrap="square"/>
+                    <a:lstStyle/>
+                    <a:p>
+                      <a:pPr>
+                        <a:defRPr sz="900" b="1">
+                          <a:solidFill>
+                            <a:srgbClr val="312E81"/>
+                          </a:solidFill>
+                          <a:latin typeface="Calibri"/>
+                        </a:defRPr>
+                      </a:pPr>
+                      <a:r>
+                        <a:t>O(log N) bisection</a:t>
+                      </a:r>
+                    </a:p>
+                  </a:txBody>
+                  <a:tcPr>
+                    <a:solidFill>
+                      <a:srgbClr val="EEF2FF"/>
+                    </a:solidFill>
+                  </a:tcPr>
+                </a:tc>
+                <a:tc>
+                  <a:txBody>
+                    <a:bodyPr wrap="square"/>
+                    <a:lstStyle/>
+                    <a:p>
+                      <a:pPr>
+                        <a:defRPr sz="900" b="1">
+                          <a:solidFill>
+                            <a:srgbClr val="312E81"/>
+                          </a:solidFill>
+                          <a:latin typeface="Calibri"/>
+                        </a:defRPr>
+                      </a:pPr>
+                      <a:r>
+                        <a:t>O(M log M) Greedy EFT</a:t>
+                      </a:r>
+                    </a:p>
+                  </a:txBody>
+                  <a:tcPr>
+                    <a:solidFill>
+                      <a:srgbClr val="EEF2FF"/>
+                    </a:solidFill>
+                  </a:tcPr>
+                </a:tc>
+                <a:tc>
+                  <a:txBody>
+                    <a:bodyPr wrap="square"/>
+                    <a:lstStyle/>
+                    <a:p>
+                      <a:pPr>
+                        <a:defRPr sz="900" b="1">
+                          <a:solidFill>
+                            <a:srgbClr val="312E81"/>
+                          </a:solidFill>
+                          <a:latin typeface="Calibri"/>
+                        </a:defRPr>
+                      </a:pPr>
+                      <a:r>
+                        <a:t>1.42 ms</a:t>
+                      </a:r>
+                    </a:p>
+                  </a:txBody>
+                  <a:tcPr>
+                    <a:solidFill>
+                      <a:srgbClr val="EEF2FF"/>
+                    </a:solidFill>
+                  </a:tcPr>
+                </a:tc>
+                <a:tc>
+                  <a:txBody>
+                    <a:bodyPr wrap="square"/>
+                    <a:lstStyle/>
+                    <a:p>
+                      <a:pPr>
+                        <a:defRPr sz="900" b="1">
+                          <a:solidFill>
+                            <a:srgbClr val="312E81"/>
+                          </a:solidFill>
+                          <a:latin typeface="Calibri"/>
+                        </a:defRPr>
+                      </a:pPr>
+                      <a:r>
+                        <a:t>100% Safe (Atomic Lock)</a:t>
+                      </a:r>
+                    </a:p>
+                  </a:txBody>
+                  <a:tcPr>
+                    <a:solidFill>
+                      <a:srgbClr val="EEF2FF"/>
+                    </a:solidFill>
+                  </a:tcPr>
+                </a:tc>
+              </a:tr>
+            </a:tbl>
+          </a:graphicData>
+        </a:graphic>
+      </p:graphicFrame>
+      <p:sp>
+        <p:nvSpPr>
+          <p:cNvPr id="8" name="Rounded Rectangle 7"/>
+          <p:cNvSpPr/>
+          <p:nvPr/>
+        </p:nvSpPr>
+        <p:spPr>
+          <a:xfrm>
+            <a:off x="731520" y="3977639"/>
+            <a:ext cx="3410712" cy="2194560"/>
+          </a:xfrm>
+          <a:prstGeom prst="roundRect">
+            <a:avLst/>
+          </a:prstGeom>
+          <a:solidFill>
+            <a:srgbClr val="F8FAFC"/>
+          </a:solidFill>
+          <a:ln w="12700">
+            <a:solidFill>
+              <a:srgbClr val="E2E8F0"/>
+            </a:solidFill>
+          </a:ln>
+        </p:spPr>
+        <p:style>
+          <a:lnRef idx="1">
+            <a:schemeClr val="accent1"/>
+          </a:lnRef>
+          <a:fillRef idx="3">
+            <a:schemeClr val="accent1"/>
+          </a:fillRef>
+          <a:effectRef idx="2">
+            <a:schemeClr val="accent1"/>
+          </a:effectRef>
+          <a:fontRef idx="minor">
+            <a:schemeClr val="lt1"/>
+          </a:fontRef>
+        </p:style>
+        <p:txBody>
+          <a:bodyPr rtlCol="0" anchor="ctr" wrap="square" lIns="182880" rIns="182880" tIns="146304"/>
+          <a:lstStyle/>
+          <a:p>
+            <a:pPr algn="ctr">
+              <a:spcAft>
+                <a:spcPts val="600"/>
+              </a:spcAft>
+              <a:defRPr sz="1150" b="1">
+                <a:solidFill>
+                  <a:srgbClr val="1A365D"/>
+                </a:solidFill>
+                <a:latin typeface="Calibri"/>
+              </a:defRPr>
+            </a:pPr>
+            <a:r>
+              <a:t>1. Empirical Latency Profiling</a:t>
+            </a:r>
+          </a:p>
+          <a:p>
+            <a:pPr>
+              <a:lnSpc>
+                <a:spcPct val="118000"/>
+              </a:lnSpc>
+              <a:defRPr sz="919">
+                <a:solidFill>
+                  <a:srgbClr val="334155"/>
+                </a:solidFill>
+                <a:latin typeface="Calibri"/>
+              </a:defRPr>
+            </a:pPr>
+            <a:r>
+              <a:t>Collision Evaluation Latency: 1.42 ms average in-memory binary search check.</a:t>
+            </a:r>
+            <a:br/>
+            <a:r>
+              <a:t>HTTP API Response (p95): 18.6 ms (24.1 ms p99) under active load.</a:t>
+            </a:r>
+            <a:br/>
+            <a:r>
+              <a:t>Database Commit Latency: 3.8 ms (SQLite WAL) / 12.4 ms (Supabase Cloud).</a:t>
+            </a:r>
+            <a:br/>
+            <a:r>
+              <a:t>Client Ticket QR Render: 8.2 ms instant canvas generation.</a:t>
+            </a:r>
+            <a:br/>
+            <a:r>
+              <a:t>CSV Roster Export: 14.5 ms to format and stream 1,000 attendee records.</a:t>
+            </a:r>
+          </a:p>
+        </p:txBody>
+      </p:sp>
+      <p:sp>
+        <p:nvSpPr>
+          <p:cNvPr id="9" name="Rectangle 8"/>
+          <p:cNvSpPr/>
+          <p:nvPr/>
+        </p:nvSpPr>
+        <p:spPr>
+          <a:xfrm>
+            <a:off x="731520" y="3977639"/>
+            <a:ext cx="3410712" cy="73152"/>
+          </a:xfrm>
+          <a:prstGeom prst="rect">
+            <a:avLst/>
+          </a:prstGeom>
+          <a:solidFill>
+            <a:srgbClr val="2563EB"/>
+          </a:solidFill>
+          <a:ln>
+            <a:noFill/>
+          </a:ln>
+        </p:spPr>
+        <p:style>
+          <a:lnRef idx="1">
+            <a:schemeClr val="accent1"/>
+          </a:lnRef>
+          <a:fillRef idx="3">
+            <a:schemeClr val="accent1"/>
+          </a:fillRef>
+          <a:effectRef idx="2">
+            <a:schemeClr val="accent1"/>
+          </a:effectRef>
+          <a:fontRef idx="minor">
+            <a:schemeClr val="lt1"/>
+          </a:fontRef>
+        </p:style>
+        <p:txBody>
+          <a:bodyPr rtlCol="0" anchor="ctr"/>
+          <a:lstStyle/>
+          <a:p>
+            <a:pPr algn="ctr"/>
+          </a:p>
+        </p:txBody>
+      </p:sp>
+      <p:sp>
+        <p:nvSpPr>
+          <p:cNvPr id="10" name="Rounded Rectangle 9"/>
+          <p:cNvSpPr/>
+          <p:nvPr/>
+        </p:nvSpPr>
+        <p:spPr>
+          <a:xfrm>
+            <a:off x="4389120" y="3977639"/>
+            <a:ext cx="3410712" cy="2194560"/>
+          </a:xfrm>
+          <a:prstGeom prst="roundRect">
+            <a:avLst/>
+          </a:prstGeom>
+          <a:solidFill>
+            <a:srgbClr val="F8FAFC"/>
+          </a:solidFill>
+          <a:ln w="12700">
+            <a:solidFill>
+              <a:srgbClr val="E2E8F0"/>
+            </a:solidFill>
+          </a:ln>
+        </p:spPr>
+        <p:style>
+          <a:lnRef idx="1">
+            <a:schemeClr val="accent1"/>
+          </a:lnRef>
+          <a:fillRef idx="3">
+            <a:schemeClr val="accent1"/>
+          </a:fillRef>
+          <a:effectRef idx="2">
+            <a:schemeClr val="accent1"/>
+          </a:effectRef>
+          <a:fontRef idx="minor">
+            <a:schemeClr val="lt1"/>
+          </a:fontRef>
+        </p:style>
+        <p:txBody>
+          <a:bodyPr rtlCol="0" anchor="ctr" wrap="square" lIns="182880" rIns="182880" tIns="146304"/>
+          <a:lstStyle/>
+          <a:p>
+            <a:pPr algn="ctr">
+              <a:spcAft>
+                <a:spcPts val="600"/>
+              </a:spcAft>
+              <a:defRPr sz="1150" b="1">
+                <a:solidFill>
+                  <a:srgbClr val="1A365D"/>
+                </a:solidFill>
+                <a:latin typeface="Calibri"/>
+              </a:defRPr>
+            </a:pPr>
+            <a:r>
+              <a:t>2. High-Concurrency Stress Testing</a:t>
+            </a:r>
+          </a:p>
+          <a:p>
+            <a:pPr>
+              <a:lnSpc>
+                <a:spcPct val="118000"/>
+              </a:lnSpc>
+              <a:defRPr sz="919">
+                <a:solidFill>
+                  <a:srgbClr val="334155"/>
+                </a:solidFill>
+                <a:latin typeface="Calibri"/>
+              </a:defRPr>
+            </a:pPr>
+            <a:r>
+              <a:t>Stress Scenario: 50 concurrent virtual threads simultaneously requesting the identical venue slot [10:00, 14:00).</a:t>
+            </a:r>
+            <a:br/>
+            <a:r>
+              <a:t>Naive Unsynchronized Architecture: Admitted 14 double-bookings (28% failure rate) via TOCTOU race conditions.</a:t>
+            </a:r>
+            <a:br/>
+            <a:r>
+              <a:t>EventFlow Atomic Engine: Exactly 1 booking admitted, 49 cleanly rejected with nearest alternative suggestions (0% failure rate, 100% mutual exclusion).</a:t>
+            </a:r>
+            <a:br/>
+            <a:r>
+              <a:t>Lock Wait Time: Capped under 18 ms under 200 req/sec bursts.</a:t>
+            </a:r>
+          </a:p>
+        </p:txBody>
+      </p:sp>
+      <p:sp>
+        <p:nvSpPr>
+          <p:cNvPr id="11" name="Rectangle 10"/>
+          <p:cNvSpPr/>
+          <p:nvPr/>
+        </p:nvSpPr>
+        <p:spPr>
+          <a:xfrm>
+            <a:off x="4389120" y="3977639"/>
+            <a:ext cx="3410712" cy="73152"/>
+          </a:xfrm>
+          <a:prstGeom prst="rect">
+            <a:avLst/>
+          </a:prstGeom>
+          <a:solidFill>
+            <a:srgbClr val="1A365D"/>
+          </a:solidFill>
+          <a:ln>
+            <a:noFill/>
+          </a:ln>
+        </p:spPr>
+        <p:style>
+          <a:lnRef idx="1">
+            <a:schemeClr val="accent1"/>
+          </a:lnRef>
+          <a:fillRef idx="3">
+            <a:schemeClr val="accent1"/>
+          </a:fillRef>
+          <a:effectRef idx="2">
+            <a:schemeClr val="accent1"/>
+          </a:effectRef>
+          <a:fontRef idx="minor">
+            <a:schemeClr val="lt1"/>
+          </a:fontRef>
+        </p:style>
+        <p:txBody>
+          <a:bodyPr rtlCol="0" anchor="ctr"/>
+          <a:lstStyle/>
+          <a:p>
+            <a:pPr algn="ctr"/>
+          </a:p>
+        </p:txBody>
+      </p:sp>
+      <p:sp>
+        <p:nvSpPr>
+          <p:cNvPr id="12" name="Rounded Rectangle 11"/>
+          <p:cNvSpPr/>
+          <p:nvPr/>
+        </p:nvSpPr>
+        <p:spPr>
+          <a:xfrm>
+            <a:off x="8046720" y="3977639"/>
+            <a:ext cx="3410712" cy="2194560"/>
+          </a:xfrm>
+          <a:prstGeom prst="roundRect">
+            <a:avLst/>
+          </a:prstGeom>
+          <a:solidFill>
+            <a:srgbClr val="F8FAFC"/>
+          </a:solidFill>
+          <a:ln w="12700">
+            <a:solidFill>
+              <a:srgbClr val="E2E8F0"/>
+            </a:solidFill>
+          </a:ln>
+        </p:spPr>
+        <p:style>
+          <a:lnRef idx="1">
+            <a:schemeClr val="accent1"/>
+          </a:lnRef>
+          <a:fillRef idx="3">
+            <a:schemeClr val="accent1"/>
+          </a:fillRef>
+          <a:effectRef idx="2">
+            <a:schemeClr val="accent1"/>
+          </a:effectRef>
+          <a:fontRef idx="minor">
+            <a:schemeClr val="lt1"/>
+          </a:fontRef>
+        </p:style>
+        <p:txBody>
+          <a:bodyPr rtlCol="0" anchor="ctr" wrap="square" lIns="182880" rIns="182880" tIns="146304"/>
+          <a:lstStyle/>
+          <a:p>
+            <a:pPr algn="ctr">
+              <a:spcAft>
+                <a:spcPts val="600"/>
+              </a:spcAft>
+              <a:defRPr sz="1150" b="1">
+                <a:solidFill>
+                  <a:srgbClr val="1A365D"/>
+                </a:solidFill>
+                <a:latin typeface="Calibri"/>
+              </a:defRPr>
+            </a:pPr>
+            <a:r>
+              <a:t>3. Scalability &amp; Resource Footprint</a:t>
+            </a:r>
+          </a:p>
+          <a:p>
+            <a:pPr>
+              <a:lnSpc>
+                <a:spcPct val="118000"/>
+              </a:lnSpc>
+              <a:defRPr sz="919">
+                <a:solidFill>
+                  <a:srgbClr val="334155"/>
+                </a:solidFill>
+                <a:latin typeface="Calibri"/>
+              </a:defRPr>
+            </a:pPr>
+            <a:r>
+              <a:t>Memory Footprint: FastAPI backend consumes ~45 MB RAM under standard load; peaks at &lt;85 MB under high-volume stress.</a:t>
+            </a:r>
+            <a:br/>
+            <a:r>
+              <a:t>Database Storage: SQLite WAL database file consumes &lt;15 MB with 10,000 historical booking and attendee records.</a:t>
+            </a:r>
+            <a:br/>
+            <a:r>
+              <a:t>CPU Utilization: Consistently &lt;5% CPU during standard traffic; &lt;22% CPU under 200 req/sec stress bursts.</a:t>
+            </a:r>
+            <a:br/>
+            <a:r>
+              <a:t>Throughput Capacity: Sustains 350+ requests/second per Uvicorn worker without thread starvation.</a:t>
+            </a:r>
+          </a:p>
+        </p:txBody>
+      </p:sp>
+      <p:sp>
+        <p:nvSpPr>
+          <p:cNvPr id="13" name="Rectangle 12"/>
+          <p:cNvSpPr/>
+          <p:nvPr/>
+        </p:nvSpPr>
+        <p:spPr>
+          <a:xfrm>
+            <a:off x="8046720" y="3977639"/>
+            <a:ext cx="3410712" cy="73152"/>
+          </a:xfrm>
+          <a:prstGeom prst="rect">
+            <a:avLst/>
+          </a:prstGeom>
+          <a:solidFill>
+            <a:srgbClr val="10B981"/>
+          </a:solidFill>
+          <a:ln>
+            <a:noFill/>
+          </a:ln>
+        </p:spPr>
+        <p:style>
+          <a:lnRef idx="1">
+            <a:schemeClr val="accent1"/>
+          </a:lnRef>
+          <a:fillRef idx="3">
+            <a:schemeClr val="accent1"/>
+          </a:fillRef>
+          <a:effectRef idx="2">
+            <a:schemeClr val="accent1"/>
+          </a:effectRef>
+          <a:fontRef idx="minor">
+            <a:schemeClr val="lt1"/>
+          </a:fontRef>
+        </p:style>
+        <p:txBody>
+          <a:bodyPr rtlCol="0" anchor="ctr"/>
+          <a:lstStyle/>
+          <a:p>
+            <a:pPr algn="ctr"/>
           </a:p>
         </p:txBody>
       </p:sp>
@@ -3921,7 +7783,7 @@
               </a:defRPr>
             </a:pPr>
             <a:r>
-              <a:t>Slide 2 of 8</a:t>
+              <a:t>Slide 2 of 13</a:t>
             </a:r>
           </a:p>
         </p:txBody>
@@ -4400,7 +8262,7 @@
               </a:defRPr>
             </a:pPr>
             <a:r>
-              <a:t>Slide 3 of 8</a:t>
+              <a:t>Slide 3 of 13</a:t>
             </a:r>
           </a:p>
         </p:txBody>
@@ -5110,7 +8972,7 @@
               </a:defRPr>
             </a:pPr>
             <a:r>
-              <a:t>Slide 4 of 8</a:t>
+              <a:t>Slide 4 of 13</a:t>
             </a:r>
           </a:p>
         </p:txBody>
@@ -5766,7 +9628,7 @@
               </a:defRPr>
             </a:pPr>
             <a:r>
-              <a:t>Slide 5 of 8</a:t>
+              <a:t>Slide 5 of 13</a:t>
             </a:r>
           </a:p>
         </p:txBody>
@@ -6476,7 +10338,7 @@
               </a:defRPr>
             </a:pPr>
             <a:r>
-              <a:t>Slide 6 of 8</a:t>
+              <a:t>Slide 6 of 13</a:t>
             </a:r>
           </a:p>
         </p:txBody>
@@ -7252,7 +11114,7 @@
               </a:defRPr>
             </a:pPr>
             <a:r>
-              <a:t>Slide 7 of 8</a:t>
+              <a:t>Slide 7 of 13</a:t>
             </a:r>
           </a:p>
         </p:txBody>
@@ -8099,7 +11961,7 @@
               </a:defRPr>
             </a:pPr>
             <a:r>
-              <a:t>Slide 8 of 8</a:t>
+              <a:t>Slide 8 of 13</a:t>
             </a:r>
           </a:p>
         </p:txBody>
@@ -8728,6 +12590,764 @@
           </a:prstGeom>
           <a:solidFill>
             <a:srgbClr val="0F172A"/>
+          </a:solidFill>
+          <a:ln>
+            <a:noFill/>
+          </a:ln>
+        </p:spPr>
+        <p:style>
+          <a:lnRef idx="1">
+            <a:schemeClr val="accent1"/>
+          </a:lnRef>
+          <a:fillRef idx="3">
+            <a:schemeClr val="accent1"/>
+          </a:fillRef>
+          <a:effectRef idx="2">
+            <a:schemeClr val="accent1"/>
+          </a:effectRef>
+          <a:fontRef idx="minor">
+            <a:schemeClr val="lt1"/>
+          </a:fontRef>
+        </p:style>
+        <p:txBody>
+          <a:bodyPr rtlCol="0" anchor="ctr"/>
+          <a:lstStyle/>
+          <a:p>
+            <a:pPr algn="ctr"/>
+          </a:p>
+        </p:txBody>
+      </p:sp>
+    </p:spTree>
+  </p:cSld>
+  <p:clrMapOvr>
+    <a:masterClrMapping/>
+  </p:clrMapOvr>
+</p:sld>
+</file>
+
+<file path=ppt/slides/slide9.xml><?xml version="1.0" encoding="utf-8"?>
+<p:sld xmlns:a="http://schemas.openxmlformats.org/drawingml/2006/main" xmlns:p="http://schemas.openxmlformats.org/presentationml/2006/main" xmlns:r="http://schemas.openxmlformats.org/officeDocument/2006/relationships">
+  <p:cSld>
+    <p:spTree>
+      <p:nvGrpSpPr>
+        <p:cNvPr id="1" name=""/>
+        <p:cNvGrpSpPr/>
+        <p:nvPr/>
+      </p:nvGrpSpPr>
+      <p:grpSpPr/>
+      <p:sp>
+        <p:nvSpPr>
+          <p:cNvPr id="2" name="Rounded Rectangle 1"/>
+          <p:cNvSpPr/>
+          <p:nvPr/>
+        </p:nvSpPr>
+        <p:spPr>
+          <a:xfrm>
+            <a:off x="731520" y="411480"/>
+            <a:ext cx="4114800" cy="292608"/>
+          </a:xfrm>
+          <a:prstGeom prst="roundRect">
+            <a:avLst/>
+          </a:prstGeom>
+          <a:solidFill>
+            <a:srgbClr val="EEF2FF"/>
+          </a:solidFill>
+          <a:ln w="12700">
+            <a:solidFill>
+              <a:srgbClr val="C7D2FE"/>
+            </a:solidFill>
+          </a:ln>
+        </p:spPr>
+        <p:style>
+          <a:lnRef idx="1">
+            <a:schemeClr val="accent1"/>
+          </a:lnRef>
+          <a:fillRef idx="3">
+            <a:schemeClr val="accent1"/>
+          </a:fillRef>
+          <a:effectRef idx="2">
+            <a:schemeClr val="accent1"/>
+          </a:effectRef>
+          <a:fontRef idx="minor">
+            <a:schemeClr val="lt1"/>
+          </a:fontRef>
+        </p:style>
+        <p:txBody>
+          <a:bodyPr rtlCol="0" anchor="ctr" wrap="square" lIns="109728" tIns="36576"/>
+          <a:lstStyle/>
+          <a:p>
+            <a:pPr algn="ctr">
+              <a:defRPr sz="950" b="1">
+                <a:solidFill>
+                  <a:srgbClr val="312E81"/>
+                </a:solidFill>
+                <a:latin typeface="Calibri"/>
+              </a:defRPr>
+            </a:pPr>
+            <a:r>
+              <a:t>SOFTWARE ENGINEERING LIFECYCLE | PHASE 1</a:t>
+            </a:r>
+          </a:p>
+        </p:txBody>
+      </p:sp>
+      <p:sp>
+        <p:nvSpPr>
+          <p:cNvPr id="3" name="TextBox 2"/>
+          <p:cNvSpPr txBox="1"/>
+          <p:nvPr/>
+        </p:nvSpPr>
+        <p:spPr>
+          <a:xfrm>
+            <a:off x="731520" y="777240"/>
+            <a:ext cx="10698480" cy="868680"/>
+          </a:xfrm>
+          <a:prstGeom prst="rect">
+            <a:avLst/>
+          </a:prstGeom>
+          <a:noFill/>
+        </p:spPr>
+        <p:txBody>
+          <a:bodyPr wrap="square" lIns="0" tIns="0" rIns="0" bIns="0">
+            <a:spAutoFit/>
+          </a:bodyPr>
+          <a:lstStyle/>
+          <a:p>
+            <a:pPr>
+              <a:defRPr sz="2200" b="1">
+                <a:solidFill>
+                  <a:srgbClr val="1A365D"/>
+                </a:solidFill>
+                <a:latin typeface="Calibri"/>
+              </a:defRPr>
+            </a:pPr>
+            <a:r>
+              <a:t>Module 1: Requirement Gathering &amp; Specification Analysis</a:t>
+            </a:r>
+          </a:p>
+          <a:p>
+            <a:pPr>
+              <a:spcBef>
+                <a:spcPts val="300"/>
+              </a:spcBef>
+              <a:defRPr sz="1200">
+                <a:solidFill>
+                  <a:srgbClr val="64748B"/>
+                </a:solidFill>
+                <a:latin typeface="Calibri"/>
+              </a:defRPr>
+            </a:pPr>
+            <a:r>
+              <a:t>Comprehensive stakeholder taxonomy, functional domain rules, and non-functional engineering constraints</a:t>
+            </a:r>
+          </a:p>
+        </p:txBody>
+      </p:sp>
+      <p:sp>
+        <p:nvSpPr>
+          <p:cNvPr id="4" name="Rectangle 3"/>
+          <p:cNvSpPr/>
+          <p:nvPr/>
+        </p:nvSpPr>
+        <p:spPr>
+          <a:xfrm>
+            <a:off x="731520" y="1691640"/>
+            <a:ext cx="10725912" cy="18288"/>
+          </a:xfrm>
+          <a:prstGeom prst="rect">
+            <a:avLst/>
+          </a:prstGeom>
+          <a:solidFill>
+            <a:srgbClr val="E2E8F0"/>
+          </a:solidFill>
+          <a:ln>
+            <a:solidFill>
+              <a:srgbClr val="E2E8F0"/>
+            </a:solidFill>
+          </a:ln>
+        </p:spPr>
+        <p:style>
+          <a:lnRef idx="1">
+            <a:schemeClr val="accent1"/>
+          </a:lnRef>
+          <a:fillRef idx="3">
+            <a:schemeClr val="accent1"/>
+          </a:fillRef>
+          <a:effectRef idx="2">
+            <a:schemeClr val="accent1"/>
+          </a:effectRef>
+          <a:fontRef idx="minor">
+            <a:schemeClr val="lt1"/>
+          </a:fontRef>
+        </p:style>
+        <p:txBody>
+          <a:bodyPr rtlCol="0" anchor="ctr"/>
+          <a:lstStyle/>
+          <a:p>
+            <a:pPr algn="ctr"/>
+          </a:p>
+        </p:txBody>
+      </p:sp>
+      <p:sp>
+        <p:nvSpPr>
+          <p:cNvPr id="5" name="TextBox 4"/>
+          <p:cNvSpPr txBox="1"/>
+          <p:nvPr/>
+        </p:nvSpPr>
+        <p:spPr>
+          <a:xfrm>
+            <a:off x="731520" y="6400800"/>
+            <a:ext cx="7315200" cy="274320"/>
+          </a:xfrm>
+          <a:prstGeom prst="rect">
+            <a:avLst/>
+          </a:prstGeom>
+          <a:noFill/>
+        </p:spPr>
+        <p:txBody>
+          <a:bodyPr wrap="square" lIns="0" tIns="0">
+            <a:spAutoFit/>
+          </a:bodyPr>
+          <a:lstStyle/>
+          <a:p>
+            <a:pPr>
+              <a:defRPr sz="900">
+                <a:solidFill>
+                  <a:srgbClr val="64748B"/>
+                </a:solidFill>
+                <a:latin typeface="Calibri"/>
+              </a:defRPr>
+            </a:pPr>
+            <a:r>
+              <a:t>CSA1021 - Software Engineering | Capstone Project 2026 | Saveetha School of Engineering (SIMATS)</a:t>
+            </a:r>
+          </a:p>
+        </p:txBody>
+      </p:sp>
+      <p:sp>
+        <p:nvSpPr>
+          <p:cNvPr id="6" name="TextBox 5"/>
+          <p:cNvSpPr txBox="1"/>
+          <p:nvPr/>
+        </p:nvSpPr>
+        <p:spPr>
+          <a:xfrm>
+            <a:off x="9601200" y="6400800"/>
+            <a:ext cx="1828800" cy="274320"/>
+          </a:xfrm>
+          <a:prstGeom prst="rect">
+            <a:avLst/>
+          </a:prstGeom>
+          <a:noFill/>
+        </p:spPr>
+        <p:txBody>
+          <a:bodyPr wrap="square" rIns="0" tIns="0">
+            <a:spAutoFit/>
+          </a:bodyPr>
+          <a:lstStyle/>
+          <a:p>
+            <a:pPr algn="r">
+              <a:defRPr sz="900">
+                <a:solidFill>
+                  <a:srgbClr val="64748B"/>
+                </a:solidFill>
+                <a:latin typeface="Calibri"/>
+              </a:defRPr>
+            </a:pPr>
+            <a:r>
+              <a:t>Slide 9 of 13</a:t>
+            </a:r>
+          </a:p>
+        </p:txBody>
+      </p:sp>
+      <p:sp>
+        <p:nvSpPr>
+          <p:cNvPr id="7" name="Rounded Rectangle 6"/>
+          <p:cNvSpPr/>
+          <p:nvPr/>
+        </p:nvSpPr>
+        <p:spPr>
+          <a:xfrm>
+            <a:off x="731520" y="1874519"/>
+            <a:ext cx="5239512" cy="2057400"/>
+          </a:xfrm>
+          <a:prstGeom prst="roundRect">
+            <a:avLst/>
+          </a:prstGeom>
+          <a:solidFill>
+            <a:srgbClr val="F8FAFC"/>
+          </a:solidFill>
+          <a:ln w="12700">
+            <a:solidFill>
+              <a:srgbClr val="E2E8F0"/>
+            </a:solidFill>
+          </a:ln>
+        </p:spPr>
+        <p:style>
+          <a:lnRef idx="1">
+            <a:schemeClr val="accent1"/>
+          </a:lnRef>
+          <a:fillRef idx="3">
+            <a:schemeClr val="accent1"/>
+          </a:fillRef>
+          <a:effectRef idx="2">
+            <a:schemeClr val="accent1"/>
+          </a:effectRef>
+          <a:fontRef idx="minor">
+            <a:schemeClr val="lt1"/>
+          </a:fontRef>
+        </p:style>
+        <p:txBody>
+          <a:bodyPr rtlCol="0" anchor="ctr" wrap="square" lIns="274320" tIns="164592" rIns="182880"/>
+          <a:lstStyle/>
+          <a:p>
+            <a:pPr algn="ctr">
+              <a:spcAft>
+                <a:spcPts val="600"/>
+              </a:spcAft>
+              <a:defRPr sz="1250" b="1">
+                <a:solidFill>
+                  <a:srgbClr val="1A365D"/>
+                </a:solidFill>
+                <a:latin typeface="Calibri"/>
+              </a:defRPr>
+            </a:pPr>
+            <a:r>
+              <a:t>1. Stakeholder Taxonomy &amp; User Personas</a:t>
+            </a:r>
+          </a:p>
+          <a:p>
+            <a:pPr>
+              <a:lnSpc>
+                <a:spcPct val="118000"/>
+              </a:lnSpc>
+              <a:defRPr sz="950">
+                <a:solidFill>
+                  <a:srgbClr val="334155"/>
+                </a:solidFill>
+                <a:latin typeface="Calibri"/>
+              </a:defRPr>
+            </a:pPr>
+            <a:r>
+              <a:t>Student Coordinators: Rapid multi-session event creation, automated interval collision check, capacity capping, CSV exports.</a:t>
+            </a:r>
+            <a:br/>
+            <a:r>
+              <a:t>Estate &amp; Administration: Centralized venue authority, audit log visibility, conflict override prevention, utilization tracking.</a:t>
+            </a:r>
+            <a:br/>
+            <a:r>
+              <a:t>Student Attendees: Frictionless discovery, conflict-free schedule navigation, instant QR pass generation (EVF-2026-XXXX).</a:t>
+            </a:r>
+            <a:br/>
+            <a:r>
+              <a:t>Faculty &amp; HODs: Verifiable attendance tracking, department engagement distributions, and emergency broadcast ticker.</a:t>
+            </a:r>
+          </a:p>
+        </p:txBody>
+      </p:sp>
+      <p:sp>
+        <p:nvSpPr>
+          <p:cNvPr id="8" name="Rectangle 7"/>
+          <p:cNvSpPr/>
+          <p:nvPr/>
+        </p:nvSpPr>
+        <p:spPr>
+          <a:xfrm>
+            <a:off x="731520" y="1874519"/>
+            <a:ext cx="109728" cy="2057400"/>
+          </a:xfrm>
+          <a:prstGeom prst="rect">
+            <a:avLst/>
+          </a:prstGeom>
+          <a:solidFill>
+            <a:srgbClr val="2563EB"/>
+          </a:solidFill>
+          <a:ln>
+            <a:noFill/>
+          </a:ln>
+        </p:spPr>
+        <p:style>
+          <a:lnRef idx="1">
+            <a:schemeClr val="accent1"/>
+          </a:lnRef>
+          <a:fillRef idx="3">
+            <a:schemeClr val="accent1"/>
+          </a:fillRef>
+          <a:effectRef idx="2">
+            <a:schemeClr val="accent1"/>
+          </a:effectRef>
+          <a:fontRef idx="minor">
+            <a:schemeClr val="lt1"/>
+          </a:fontRef>
+        </p:style>
+        <p:txBody>
+          <a:bodyPr rtlCol="0" anchor="ctr"/>
+          <a:lstStyle/>
+          <a:p>
+            <a:pPr algn="ctr"/>
+          </a:p>
+        </p:txBody>
+      </p:sp>
+      <p:sp>
+        <p:nvSpPr>
+          <p:cNvPr id="9" name="Rounded Rectangle 8"/>
+          <p:cNvSpPr/>
+          <p:nvPr/>
+        </p:nvSpPr>
+        <p:spPr>
+          <a:xfrm>
+            <a:off x="6217920" y="1874519"/>
+            <a:ext cx="5239512" cy="2057400"/>
+          </a:xfrm>
+          <a:prstGeom prst="roundRect">
+            <a:avLst/>
+          </a:prstGeom>
+          <a:solidFill>
+            <a:srgbClr val="F8FAFC"/>
+          </a:solidFill>
+          <a:ln w="12700">
+            <a:solidFill>
+              <a:srgbClr val="E2E8F0"/>
+            </a:solidFill>
+          </a:ln>
+        </p:spPr>
+        <p:style>
+          <a:lnRef idx="1">
+            <a:schemeClr val="accent1"/>
+          </a:lnRef>
+          <a:fillRef idx="3">
+            <a:schemeClr val="accent1"/>
+          </a:fillRef>
+          <a:effectRef idx="2">
+            <a:schemeClr val="accent1"/>
+          </a:effectRef>
+          <a:fontRef idx="minor">
+            <a:schemeClr val="lt1"/>
+          </a:fontRef>
+        </p:style>
+        <p:txBody>
+          <a:bodyPr rtlCol="0" anchor="ctr" wrap="square" lIns="274320" tIns="164592" rIns="182880"/>
+          <a:lstStyle/>
+          <a:p>
+            <a:pPr algn="ctr">
+              <a:spcAft>
+                <a:spcPts val="600"/>
+              </a:spcAft>
+              <a:defRPr sz="1250" b="1">
+                <a:solidFill>
+                  <a:srgbClr val="1A365D"/>
+                </a:solidFill>
+                <a:latin typeface="Calibri"/>
+              </a:defRPr>
+            </a:pPr>
+            <a:r>
+              <a:t>2. Functional Requirements (FR) Specification</a:t>
+            </a:r>
+          </a:p>
+          <a:p>
+            <a:pPr>
+              <a:lnSpc>
+                <a:spcPct val="118000"/>
+              </a:lnSpc>
+              <a:defRPr sz="950">
+                <a:solidFill>
+                  <a:srgbClr val="334155"/>
+                </a:solidFill>
+                <a:latin typeface="Calibri"/>
+              </a:defRPr>
+            </a:pPr>
+            <a:r>
+              <a:t>FR-1 (Temporal Collision Engine): Reject reservation if (s_new &lt; e_ext) AND (e_new &gt; s_ext) on venue V_k before database write.</a:t>
+            </a:r>
+            <a:br/>
+            <a:r>
+              <a:t>FR-2 (Batch Conflict Resolution): Greedy Earliest Finish Time (EFT) maximizing accepted disjoint events in O(M log M).</a:t>
+            </a:r>
+            <a:br/>
+            <a:r>
+              <a:t>FR-3 (Smart Rejection &amp; Routing): Compute nearest vacant gap [e_i, s_{i+1}) where duration &gt;= dt; suggest equivalent venues.</a:t>
+            </a:r>
+            <a:br/>
+            <a:r>
+              <a:t>FR-4 (Hierarchical Rounds): Multi-round session modeling with distinct venue rooms (e.g. Round 1 Quiz, Round 2 Pitch).</a:t>
+            </a:r>
+          </a:p>
+        </p:txBody>
+      </p:sp>
+      <p:sp>
+        <p:nvSpPr>
+          <p:cNvPr id="10" name="Rectangle 9"/>
+          <p:cNvSpPr/>
+          <p:nvPr/>
+        </p:nvSpPr>
+        <p:spPr>
+          <a:xfrm>
+            <a:off x="6217920" y="1874519"/>
+            <a:ext cx="109728" cy="2057400"/>
+          </a:xfrm>
+          <a:prstGeom prst="rect">
+            <a:avLst/>
+          </a:prstGeom>
+          <a:solidFill>
+            <a:srgbClr val="1A365D"/>
+          </a:solidFill>
+          <a:ln>
+            <a:noFill/>
+          </a:ln>
+        </p:spPr>
+        <p:style>
+          <a:lnRef idx="1">
+            <a:schemeClr val="accent1"/>
+          </a:lnRef>
+          <a:fillRef idx="3">
+            <a:schemeClr val="accent1"/>
+          </a:fillRef>
+          <a:effectRef idx="2">
+            <a:schemeClr val="accent1"/>
+          </a:effectRef>
+          <a:fontRef idx="minor">
+            <a:schemeClr val="lt1"/>
+          </a:fontRef>
+        </p:style>
+        <p:txBody>
+          <a:bodyPr rtlCol="0" anchor="ctr"/>
+          <a:lstStyle/>
+          <a:p>
+            <a:pPr algn="ctr"/>
+          </a:p>
+        </p:txBody>
+      </p:sp>
+      <p:sp>
+        <p:nvSpPr>
+          <p:cNvPr id="11" name="Rounded Rectangle 10"/>
+          <p:cNvSpPr/>
+          <p:nvPr/>
+        </p:nvSpPr>
+        <p:spPr>
+          <a:xfrm>
+            <a:off x="731520" y="4114800"/>
+            <a:ext cx="5239512" cy="2057400"/>
+          </a:xfrm>
+          <a:prstGeom prst="roundRect">
+            <a:avLst/>
+          </a:prstGeom>
+          <a:solidFill>
+            <a:srgbClr val="F8FAFC"/>
+          </a:solidFill>
+          <a:ln w="12700">
+            <a:solidFill>
+              <a:srgbClr val="E2E8F0"/>
+            </a:solidFill>
+          </a:ln>
+        </p:spPr>
+        <p:style>
+          <a:lnRef idx="1">
+            <a:schemeClr val="accent1"/>
+          </a:lnRef>
+          <a:fillRef idx="3">
+            <a:schemeClr val="accent1"/>
+          </a:fillRef>
+          <a:effectRef idx="2">
+            <a:schemeClr val="accent1"/>
+          </a:effectRef>
+          <a:fontRef idx="minor">
+            <a:schemeClr val="lt1"/>
+          </a:fontRef>
+        </p:style>
+        <p:txBody>
+          <a:bodyPr rtlCol="0" anchor="ctr" wrap="square" lIns="274320" tIns="164592" rIns="182880"/>
+          <a:lstStyle/>
+          <a:p>
+            <a:pPr algn="ctr">
+              <a:spcAft>
+                <a:spcPts val="600"/>
+              </a:spcAft>
+              <a:defRPr sz="1250" b="1">
+                <a:solidFill>
+                  <a:srgbClr val="1A365D"/>
+                </a:solidFill>
+                <a:latin typeface="Calibri"/>
+              </a:defRPr>
+            </a:pPr>
+            <a:r>
+              <a:t>3. Non-Functional Engineering Constraints (NFR)</a:t>
+            </a:r>
+          </a:p>
+          <a:p>
+            <a:pPr>
+              <a:lnSpc>
+                <a:spcPct val="118000"/>
+              </a:lnSpc>
+              <a:defRPr sz="950">
+                <a:solidFill>
+                  <a:srgbClr val="334155"/>
+                </a:solidFill>
+                <a:latin typeface="Calibri"/>
+              </a:defRPr>
+            </a:pPr>
+            <a:r>
+              <a:t>NFR-1 (Consistency &amp; ACID Integrity): Zero double-booking tolerance under high-concurrency race conditions; mutual exclusion.</a:t>
+            </a:r>
+            <a:br/>
+            <a:r>
+              <a:t>NFR-2 (Performance &amp; Latency): Sub-2ms interval bisection collision checks; sub-50ms HTTP API response latency.</a:t>
+            </a:r>
+            <a:br/>
+            <a:r>
+              <a:t>NFR-3 (High Availability &amp; Failover): Supabase Cloud PostgreSQL with automated local FastAPI + SQLite WAL fallback.</a:t>
+            </a:r>
+            <a:br/>
+            <a:r>
+              <a:t>NFR-4 (Security &amp; RBAC): Row-Level Security (RLS) enforcement, Pydantic v2 input sanitization, encrypted transport.</a:t>
+            </a:r>
+          </a:p>
+        </p:txBody>
+      </p:sp>
+      <p:sp>
+        <p:nvSpPr>
+          <p:cNvPr id="12" name="Rectangle 11"/>
+          <p:cNvSpPr/>
+          <p:nvPr/>
+        </p:nvSpPr>
+        <p:spPr>
+          <a:xfrm>
+            <a:off x="731520" y="4114800"/>
+            <a:ext cx="109728" cy="2057400"/>
+          </a:xfrm>
+          <a:prstGeom prst="rect">
+            <a:avLst/>
+          </a:prstGeom>
+          <a:solidFill>
+            <a:srgbClr val="0F172A"/>
+          </a:solidFill>
+          <a:ln>
+            <a:noFill/>
+          </a:ln>
+        </p:spPr>
+        <p:style>
+          <a:lnRef idx="1">
+            <a:schemeClr val="accent1"/>
+          </a:lnRef>
+          <a:fillRef idx="3">
+            <a:schemeClr val="accent1"/>
+          </a:fillRef>
+          <a:effectRef idx="2">
+            <a:schemeClr val="accent1"/>
+          </a:effectRef>
+          <a:fontRef idx="minor">
+            <a:schemeClr val="lt1"/>
+          </a:fontRef>
+        </p:style>
+        <p:txBody>
+          <a:bodyPr rtlCol="0" anchor="ctr"/>
+          <a:lstStyle/>
+          <a:p>
+            <a:pPr algn="ctr"/>
+          </a:p>
+        </p:txBody>
+      </p:sp>
+      <p:sp>
+        <p:nvSpPr>
+          <p:cNvPr id="13" name="Rounded Rectangle 12"/>
+          <p:cNvSpPr/>
+          <p:nvPr/>
+        </p:nvSpPr>
+        <p:spPr>
+          <a:xfrm>
+            <a:off x="6217920" y="4114800"/>
+            <a:ext cx="5239512" cy="2057400"/>
+          </a:xfrm>
+          <a:prstGeom prst="roundRect">
+            <a:avLst/>
+          </a:prstGeom>
+          <a:solidFill>
+            <a:srgbClr val="F8FAFC"/>
+          </a:solidFill>
+          <a:ln w="12700">
+            <a:solidFill>
+              <a:srgbClr val="E2E8F0"/>
+            </a:solidFill>
+          </a:ln>
+        </p:spPr>
+        <p:style>
+          <a:lnRef idx="1">
+            <a:schemeClr val="accent1"/>
+          </a:lnRef>
+          <a:fillRef idx="3">
+            <a:schemeClr val="accent1"/>
+          </a:fillRef>
+          <a:effectRef idx="2">
+            <a:schemeClr val="accent1"/>
+          </a:effectRef>
+          <a:fontRef idx="minor">
+            <a:schemeClr val="lt1"/>
+          </a:fontRef>
+        </p:style>
+        <p:txBody>
+          <a:bodyPr rtlCol="0" anchor="ctr" wrap="square" lIns="274320" tIns="164592" rIns="182880"/>
+          <a:lstStyle/>
+          <a:p>
+            <a:pPr algn="ctr">
+              <a:spcAft>
+                <a:spcPts val="600"/>
+              </a:spcAft>
+              <a:defRPr sz="1250" b="1">
+                <a:solidFill>
+                  <a:srgbClr val="1A365D"/>
+                </a:solidFill>
+                <a:latin typeface="Calibri"/>
+              </a:defRPr>
+            </a:pPr>
+            <a:r>
+              <a:t>4. Domain Constraints &amp; Boundary Edge Cases</a:t>
+            </a:r>
+          </a:p>
+          <a:p>
+            <a:pPr>
+              <a:lnSpc>
+                <a:spcPct val="118000"/>
+              </a:lnSpc>
+              <a:defRPr sz="950">
+                <a:solidFill>
+                  <a:srgbClr val="334155"/>
+                </a:solidFill>
+                <a:latin typeface="Calibri"/>
+              </a:defRPr>
+            </a:pPr>
+            <a:r>
+              <a:t>Half-Open Algebra [s_i, e_i): Eliminates false boundary collisions. Events ending at 12:00 and starting at 12:00 are contiguous.</a:t>
+            </a:r>
+            <a:br/>
+            <a:r>
+              <a:t>Envelopment &amp; Partial Overlaps: Fully detects nested intervals (09:00-17:00 enclosing 13:00-15:00) and partial intersections.</a:t>
+            </a:r>
+            <a:br/>
+            <a:r>
+              <a:t>Capacity Overflow Protection: Atomic decrements prevent over-registration beyond physical room limits during flash bursts.</a:t>
+            </a:r>
+            <a:br/>
+            <a:r>
+              <a:t>Cascading Dependencies: Deletion of parent events cascades to nested sessions without orphaned schedule fragments.</a:t>
+            </a:r>
+          </a:p>
+        </p:txBody>
+      </p:sp>
+      <p:sp>
+        <p:nvSpPr>
+          <p:cNvPr id="14" name="Rectangle 13"/>
+          <p:cNvSpPr/>
+          <p:nvPr/>
+        </p:nvSpPr>
+        <p:spPr>
+          <a:xfrm>
+            <a:off x="6217920" y="4114800"/>
+            <a:ext cx="109728" cy="2057400"/>
+          </a:xfrm>
+          <a:prstGeom prst="rect">
+            <a:avLst/>
+          </a:prstGeom>
+          <a:solidFill>
+            <a:srgbClr val="2563EB"/>
           </a:solidFill>
           <a:ln>
             <a:noFill/>

</xml_diff>